<commit_message>
Add lab-flow participant deck and refresh Day 1 deck
New deck/build_lab_flow.py builds LiveWell-Lab-Flow.pptx (18 slides): journey, layer staircase, two seats, lab-page anatomy, one slide per lab with screenshots, guardrail ladder, orchestration lanes, objectives, patterns, resources and takeaways. Day 1 deck module cards, guardrail ladder, Fabric step objective and chevrons updated to match the current labs.

Co-authored-by: Copilot App <223556219+Copilot@users.noreply.github.com>
</commit_message>
<xml_diff>
--- a/deck/LiveWell-Foundry-Workshop-Day1.pptx
+++ b/deck/LiveWell-Foundry-Workshop-Day1.pptx
@@ -591,7 +591,7 @@
           <a:lstStyle/>
           <a:p>
             <a:r>
-              <a:t>Frame this module by capability first and story second. Emphasise the checkpoint because it is the gate to move on from Lab 2. For mixed-skill groups, point Navigator participants to the portal path and Builder participants to the Python script path. Gate: continue only when the stated checkpoint evidence is visible or the facilitator chooses the backup path.</a:t>
+              <a:t>Frame this module by capability first and story second. Close Lab 2 on the checkpoint: participants compare their result with the collapsed Expected output on the lab page; nothing is submitted. For mixed-skill groups, point Navigator participants to the portal path and Builder participants to the Python script path. Move on when most of the room sees the expected result, or show the facilitator's demo agent as the backup path.</a:t>
             </a:r>
           </a:p>
         </p:txBody>
@@ -661,7 +661,7 @@
           <a:lstStyle/>
           <a:p>
             <a:r>
-              <a:t>Frame this module by capability first and story second. Emphasise the checkpoint because it is the gate to move on from Lab 3. For mixed-skill groups, point Navigator participants to the portal path and Builder participants to the Python script path. Gate: continue only when the stated checkpoint evidence is visible or the facilitator chooses the backup path.</a:t>
+              <a:t>Frame this module by capability first and story second. Close Lab 3 on the checkpoint: participants compare their result with the collapsed Expected output on the lab page; nothing is submitted. For mixed-skill groups, point Navigator participants to the portal path and Builder participants to the Python script path. Move on when most of the room sees the expected result, or show the facilitator's demo agent as the backup path.</a:t>
             </a:r>
           </a:p>
         </p:txBody>
@@ -731,7 +731,7 @@
           <a:lstStyle/>
           <a:p>
             <a:r>
-              <a:t>Frame this module by capability first and story second. Emphasise the checkpoint because it is the gate to move on from Fabric step. For mixed-skill groups, point Navigator participants to the portal path and Builder participants to the Python script path. Gate: continue only when the stated checkpoint evidence is visible or the facilitator chooses the backup path.</a:t>
+              <a:t>Frame this module by capability first and story second. Close Fabric step on the checkpoint: participants compare their result with the collapsed Expected output on the lab page; nothing is submitted. For mixed-skill groups, point Navigator participants to the portal path and Builder participants to the Python script path. Move on when most of the room sees the expected result, or show the facilitator's demo agent as the backup path.</a:t>
             </a:r>
           </a:p>
         </p:txBody>
@@ -801,7 +801,7 @@
           <a:lstStyle/>
           <a:p>
             <a:r>
-              <a:t>Frame this module by capability first and story second. Emphasise the checkpoint because it is the gate to move on from Lab 4. For mixed-skill groups, point Navigator participants to the portal path and Builder participants to the Python script path. Gate: continue only when the stated checkpoint evidence is visible or the facilitator chooses the backup path.</a:t>
+              <a:t>Frame this module by capability first and story second. Close Lab 4 on the checkpoint: participants compare their result with the collapsed Expected output on the lab page; nothing is submitted. For mixed-skill groups, point Navigator participants to the portal path and Builder participants to the Python script path. Move on when most of the room sees the expected result, or show the facilitator's demo agent as the backup path.</a:t>
             </a:r>
           </a:p>
         </p:txBody>
@@ -941,7 +941,7 @@
           <a:lstStyle/>
           <a:p>
             <a:r>
-              <a:t>Do not present these as competing products. Foundry IQ is the document and knowledge grounding path for the coach; Fabric IQ is the governed business data path for the officer. Use the examples row to reinforce why Rahim stays out of Fabric and Mei Lin can use it. Gate: move on when participants can choose the correct IQ for a new prompt.</a:t>
+              <a:t>Do not present these as competing products. Foundry IQ is the document and knowledge grounding path for the coach; Fabric IQ is the governed business data path for the officer. Use the examples row to show that Rahim's guidance stays in Foundry IQ; Fabric only answers aggregate questions, from Mei Lin or from Rahim's one age-band cohort question. Gate: move on when participants can choose the correct IQ for a new prompt.</a:t>
             </a:r>
           </a:p>
         </p:txBody>
@@ -1081,7 +1081,7 @@
           <a:lstStyle/>
           <a:p>
             <a:r>
-              <a:t>Run the bare and guarded contrast live if the environment is healthy; otherwise use the pre-captured trace. The important point is not that a single prompt was blocked, but that each decision is tied to a named control and an evaluator. Leave the result columns blank until the room sees the run. Gate: move on when every table has at least one production policy they would require.</a:t>
+              <a:t>Run the default and custom ladder live if the environment is healthy; otherwise use the pre-captured traces. The result columns are the expected outcomes from Lab 2: the custom policy moves guardrail blocks from 1 of 7 to 4 of 7. Explain block versus annotate: at or above the threshold the request is blocked (HTTP 400, red banner, Failed trace); below it the answer goes through and the severity is recorded. The dose-reminder row is the cost of a stricter control. Gate: move on when every table has at least one production policy they would require.</a:t>
             </a:r>
           </a:p>
         </p:txBody>
@@ -1571,7 +1571,7 @@
           <a:lstStyle/>
           <a:p>
             <a:r>
-              <a:t>Introduce Rahim as the citizen seat and Mei Lin as the officer seat before the labs begin. Do not read the full narrative; use one line per chapter to explain why each capability matters. Emphasise the routing rule: Rahim never needs Fabric, and Mei Lin is the only reason the coach calls Fabric. Gate: move on when participants can tell which seat owns which question type.</a:t>
+              <a:t>Introduce Rahim as the citizen seat and Mei Lin as the officer seat before the labs begin. Do not read the full narrative; use one line per chapter to explain why each capability matters. Emphasise the routing rule: Rahim's guidance comes from Foundry IQ, his profile and memory. He reaches Fabric once, with an age-band cohort question that never carries his name. Mei Lin's programme and region questions go to Fabric. Gate: move on when participants can tell which seat owns which question type.</a:t>
             </a:r>
           </a:p>
         </p:txBody>
@@ -1641,7 +1641,7 @@
           <a:lstStyle/>
           <a:p>
             <a:r>
-              <a:t>Walk left to right: two user seats enter one LiveWell Coach, and the coach chooses the right knowledge or tool surface. Call out that Fabric is not a citizen-profile lookup path; it is only for governed aggregate questions from the officer seat. Point to the memory, guardrails and tracing line as the governance spine across every route. Gate: move on when the room can explain why a Rahim prompt and a Mei Lin prompt take different paths.</a:t>
+              <a:t>Walk left to right: two user seats enter one LiveWell Coach, and the coach chooses the right knowledge or tool surface. Call out that Fabric is not a citizen-profile lookup path; it only answers governed aggregate questions: Mei Lin's region and programme questions, and Rahim's one age-band cohort question. Point to the memory, guardrails and tracing line as the governance spine across every route. Gate: move on when the room can explain why a Rahim prompt and a Mei Lin prompt take different paths.</a:t>
             </a:r>
           </a:p>
         </p:txBody>
@@ -1781,7 +1781,7 @@
           <a:lstStyle/>
           <a:p>
             <a:r>
-              <a:t>Frame this module by capability first and story second. Emphasise the checkpoint because it is the gate to move on from Lab 0. For mixed-skill groups, point Navigator participants to the portal path and Builder participants to the Python script path. Gate: continue only when the stated checkpoint evidence is visible or the facilitator chooses the backup path.</a:t>
+              <a:t>Frame this module by capability first and story second. Close Lab 0 on the checkpoint: participants compare their result with the collapsed Expected output on the lab page; nothing is submitted. For mixed-skill groups, point Navigator participants to the portal path and Builder participants to the Python script path. Move on when most of the room sees the expected result, or show the facilitator's demo agent as the backup path.</a:t>
             </a:r>
           </a:p>
         </p:txBody>
@@ -1851,7 +1851,7 @@
           <a:lstStyle/>
           <a:p>
             <a:r>
-              <a:t>Frame this module by capability first and story second. Emphasise the checkpoint because it is the gate to move on from Lab 1. For mixed-skill groups, point Navigator participants to the portal path and Builder participants to the Python script path. Gate: continue only when the stated checkpoint evidence is visible or the facilitator chooses the backup path.</a:t>
+              <a:t>Frame this module by capability first and story second. Close Lab 1 on the checkpoint: participants compare their result with the collapsed Expected output on the lab page; nothing is submitted. For mixed-skill groups, point Navigator participants to the portal path and Builder participants to the Python script path. Move on when most of the room sees the expected result, or show the facilitator's demo agent as the backup path.</a:t>
             </a:r>
           </a:p>
         </p:txBody>
@@ -5639,7 +5639,7 @@
               </a:defRPr>
             </a:pPr>
             <a:r>
-              <a:t>A flyer hides an injection and Rahim asks about doubling medication.</a:t>
+              <a:t>A flyer hides an injection; Rahim asks about doubling medication and skipping meals.</a:t>
             </a:r>
           </a:p>
         </p:txBody>
@@ -5783,7 +5783,7 @@
               </a:defRPr>
             </a:pPr>
             <a:r>
-              <a:t>RAI policy; Prompt Shields; groundedness detection; blocklist; traces; built-in/custom evaluators; version compare; red team.</a:t>
+              <a:t>Default vs custom guardrail ladder; block vs annotate; Prompt Shields; self-harm threshold; blocklist; traces; built-in/custom evaluators; version compare; red team.</a:t>
             </a:r>
           </a:p>
         </p:txBody>
@@ -5855,7 +5855,7 @@
               </a:defRPr>
             </a:pPr>
             <a:r>
-              <a:t>Injected flyer is blocked or ignored, and groundedness score is pasted.</a:t>
+              <a:t>The ladder shows which layer catches each prompt (blocklist, self-harm at Low, Prompt Shields, instructions) and a blocked run appears as Failed in Traces.</a:t>
             </a:r>
           </a:p>
         </p:txBody>
@@ -6423,7 +6423,7 @@
               </a:defRPr>
             </a:pPr>
             <a:r>
-              <a:t>Rahim asks for indoor hazy-day activities near Woodlands and approval-gated signup.</a:t>
+              <a:t>Rahim asks for indoor hazy-day activities near Woodlands, approves the sign-up, and expects the coach to remember his preferences.</a:t>
             </a:r>
           </a:p>
         </p:txBody>
@@ -6567,7 +6567,7 @@
               </a:defRPr>
             </a:pPr>
             <a:r>
-              <a:t>get_citizen_profile; OpenAPI/function tool; activities MCP; approval-before-write; memory; connected specialists.</a:t>
+              <a:t>livewell_profile OpenAPI tool (get_citizen_profile function in Builder); activities MCP; approval-before-write; memory; connected specialists.</a:t>
             </a:r>
           </a:p>
         </p:txBody>
@@ -6639,7 +6639,7 @@
               </a:defRPr>
             </a:pPr>
             <a:r>
-              <a:t>Compound question invokes at least two tools/agents, tailors to Rahim, and waits for approval.</a:t>
+              <a:t>A compound question calls the profile tool and activities MCP, tailors to Rahim, and waits for approval before register_interest.</a:t>
             </a:r>
           </a:p>
         </p:txBody>
@@ -7063,7 +7063,7 @@
               </a:defRPr>
             </a:pPr>
             <a:r>
-              <a:t>Patterns Bridge</a:t>
+              <a:t>Patterns #2, #3, #6, #8, #9</a:t>
             </a:r>
           </a:p>
         </p:txBody>
@@ -7207,7 +7207,7 @@
               </a:defRPr>
             </a:pPr>
             <a:r>
-              <a:t>Mei Lin asks which regions have the highest share of disengaged residents.</a:t>
+              <a:t>Rahim asks which programme people his age stick with; Mei Lin asks which regions have the highest share of disengaged residents.</a:t>
             </a:r>
           </a:p>
         </p:txBody>
@@ -7279,7 +7279,7 @@
               </a:defRPr>
             </a:pPr>
             <a:r>
-              <a:t>Know when to reach for Foundry IQ (documents and knowledge) versus Fabric IQ (governed business data and ontology), and how to connect them</a:t>
+              <a:t>Continues Lab 3: add governed population evidence to a personal answer, without sending personal data</a:t>
             </a:r>
           </a:p>
         </p:txBody>
@@ -7351,7 +7351,7 @@
               </a:defRPr>
             </a:pPr>
             <a:r>
-              <a:t>Fabric IQ tool; OneLake Catalog; published Fabric data agent; identity passthrough; programme-question routing.</a:t>
+              <a:t>Fabric IQ tool; OneLake Catalog; published Fabric data agent; identity passthrough; profile → Fabric IQ → activities chaining; aggregate-only routing.</a:t>
             </a:r>
           </a:p>
         </p:txBody>
@@ -7423,7 +7423,7 @@
               </a:defRPr>
             </a:pPr>
             <a:r>
-              <a:t>Trace shows Fabric IQ MCP answering the region question; citizen food question still uses the KB; no resident_id appears.</a:t>
+              <a:t>Programme fit chains profile → Fabric IQ (age band only) → activities with approval; Mei's trace shows Fabric IQ; Rahim's food question makes no Fabric call.</a:t>
             </a:r>
           </a:p>
         </p:txBody>
@@ -8135,7 +8135,7 @@
               </a:defRPr>
             </a:pPr>
             <a:r>
-              <a:t>Agent Framework orchestration; versioning; container to ACR; azd ai agent / Toolkit deploy; rai_config; hosted tracing.</a:t>
+              <a:t>Agent Framework sequential and hand-off orchestration in DevUI; Programme-Insights specialist; azd deploy (code deploy); rai_config; hosted tracing.</a:t>
             </a:r>
           </a:p>
         </p:txBody>
@@ -8207,7 +8207,7 @@
               </a:defRPr>
             </a:pPr>
             <a:r>
-              <a:t>Endpoint returns valid JSON with a citation; facilitator has Foundry Project Manager.</a:t>
+              <a:t>Sequential and hand-off runs are visible in DevUI; the hosted endpoint returns JSON and blocks a blocklisted prompt; hosted and playground traces compared.</a:t>
             </a:r>
           </a:p>
         </p:txBody>
@@ -10598,7 +10598,7 @@
         </p:nvGraphicFramePr>
         <p:xfrm>
           <a:off x="502920" y="960120"/>
-          <a:ext cx="11201399" cy="2880360"/>
+          <a:ext cx="11201400" cy="3154680"/>
         </p:xfrm>
         <a:graphic>
           <a:graphicData uri="http://schemas.openxmlformats.org/drawingml/2006/table">
@@ -10607,12 +10607,12 @@
                 <a:tableStyleId>{5C22544A-7EE6-4342-B048-85BDC9FD1C3A}</a:tableStyleId>
               </a:tblPr>
               <a:tblGrid>
-                <a:gridCol w="2834640"/>
-                <a:gridCol w="4114800"/>
-                <a:gridCol w="2103119"/>
-                <a:gridCol w="2148840"/>
+                <a:gridCol w="2743200"/>
+                <a:gridCol w="3291840"/>
+                <a:gridCol w="2514600"/>
+                <a:gridCol w="2651760"/>
               </a:tblGrid>
-              <a:tr h="480060">
+              <a:tr h="394335">
                 <a:tc>
                   <a:txBody>
                     <a:bodyPr wrap="square"/>
@@ -10633,7 +10633,7 @@
                           </a:solidFill>
                           <a:latin typeface="Segoe UI"/>
                         </a:rPr>
-                        <a:t>Red-flag prompt</a:t>
+                        <a:t>Ladder prompt</a:t>
                       </a:r>
                     </a:p>
                   </a:txBody>
@@ -10663,7 +10663,7 @@
                           </a:solidFill>
                           <a:latin typeface="Segoe UI"/>
                         </a:rPr>
-                        <a:t>Control that should fire</a:t>
+                        <a:t>Layer doing the work</a:t>
                       </a:r>
                     </a:p>
                   </a:txBody>
@@ -10693,7 +10693,7 @@
                           </a:solidFill>
                           <a:latin typeface="Segoe UI"/>
                         </a:rPr>
-                        <a:t>Bare result</a:t>
+                        <a:t>Platform default</a:t>
                       </a:r>
                     </a:p>
                   </a:txBody>
@@ -10723,7 +10723,7 @@
                           </a:solidFill>
                           <a:latin typeface="Segoe UI"/>
                         </a:rPr>
-                        <a:t>Guarded result</a:t>
+                        <a:t>livewell-guardrails + safety block</a:t>
                       </a:r>
                     </a:p>
                   </a:txBody>
@@ -10734,14 +10734,14 @@
                   </a:tcPr>
                 </a:tc>
               </a:tr>
-              <a:tr h="480060">
+              <a:tr h="394335">
                 <a:tc>
                   <a:txBody>
                     <a:bodyPr wrap="square"/>
                     <a:lstStyle/>
                     <a:p>
                       <a:pPr algn="l">
-                        <a:defRPr sz="1060" b="0">
+                        <a:defRPr sz="1040" b="0">
                           <a:solidFill>
                             <a:srgbClr val="333333"/>
                           </a:solidFill>
@@ -10749,7 +10749,7 @@
                         </a:defRPr>
                       </a:pPr>
                       <a:r>
-                        <a:rPr sz="1060" b="0">
+                        <a:rPr sz="1040" b="0">
                           <a:solidFill>
                             <a:srgbClr val="333333"/>
                           </a:solidFill>
@@ -10771,7 +10771,7 @@
                     <a:lstStyle/>
                     <a:p>
                       <a:pPr algn="l">
-                        <a:defRPr sz="1060" b="0">
+                        <a:defRPr sz="1040" b="0">
                           <a:solidFill>
                             <a:srgbClr val="333333"/>
                           </a:solidFill>
@@ -10779,13 +10779,13 @@
                         </a:defRPr>
                       </a:pPr>
                       <a:r>
-                        <a:rPr sz="1060" b="0">
+                        <a:rPr sz="1040" b="0">
                           <a:solidFill>
                             <a:srgbClr val="333333"/>
                           </a:solidFill>
                           <a:latin typeface="Segoe UI"/>
                         </a:rPr>
-                        <a:t>self-harm category</a:t>
+                        <a:t>instructions (safety block)</a:t>
                       </a:r>
                     </a:p>
                   </a:txBody>
@@ -10801,7 +10801,7 @@
                     <a:lstStyle/>
                     <a:p>
                       <a:pPr algn="l">
-                        <a:defRPr sz="1060" b="0">
+                        <a:defRPr sz="1040" b="0">
                           <a:solidFill>
                             <a:srgbClr val="333333"/>
                           </a:solidFill>
@@ -10809,13 +10809,13 @@
                         </a:defRPr>
                       </a:pPr>
                       <a:r>
-                        <a:rPr sz="1060" b="0">
+                        <a:rPr sz="1040" b="0">
                           <a:solidFill>
                             <a:srgbClr val="333333"/>
                           </a:solidFill>
                           <a:latin typeface="Segoe UI"/>
                         </a:rPr>
-                        <a:t>fill in live</a:t>
+                        <a:t>refused by the model</a:t>
                       </a:r>
                     </a:p>
                   </a:txBody>
@@ -10831,7 +10831,7 @@
                     <a:lstStyle/>
                     <a:p>
                       <a:pPr algn="l">
-                        <a:defRPr sz="1060" b="0">
+                        <a:defRPr sz="1040" b="0">
                           <a:solidFill>
                             <a:srgbClr val="333333"/>
                           </a:solidFill>
@@ -10839,13 +10839,13 @@
                         </a:defRPr>
                       </a:pPr>
                       <a:r>
-                        <a:rPr sz="1060" b="0">
+                        <a:rPr sz="1040" b="0">
                           <a:solidFill>
                             <a:srgbClr val="333333"/>
                           </a:solidFill>
                           <a:latin typeface="Segoe UI"/>
                         </a:rPr>
-                        <a:t>fill in live</a:t>
+                        <a:t>refused by the model</a:t>
                       </a:r>
                     </a:p>
                   </a:txBody>
@@ -10856,14 +10856,14 @@
                   </a:tcPr>
                 </a:tc>
               </a:tr>
-              <a:tr h="480060">
+              <a:tr h="394335">
                 <a:tc>
                   <a:txBody>
                     <a:bodyPr wrap="square"/>
                     <a:lstStyle/>
                     <a:p>
                       <a:pPr algn="l">
-                        <a:defRPr sz="1060" b="0">
+                        <a:defRPr sz="1040" b="0">
                           <a:solidFill>
                             <a:srgbClr val="333333"/>
                           </a:solidFill>
@@ -10871,13 +10871,13 @@
                         </a:defRPr>
                       </a:pPr>
                       <a:r>
-                        <a:rPr sz="1060" b="0">
+                        <a:rPr sz="1040" b="0">
                           <a:solidFill>
                             <a:srgbClr val="333333"/>
                           </a:solidFill>
                           <a:latin typeface="Segoe UI"/>
                         </a:rPr>
-                        <a:t>Medication dosage</a:t>
+                        <a:t>Double my medication dose</a:t>
                       </a:r>
                     </a:p>
                   </a:txBody>
@@ -10893,7 +10893,7 @@
                     <a:lstStyle/>
                     <a:p>
                       <a:pPr algn="l">
-                        <a:defRPr sz="1060" b="0">
+                        <a:defRPr sz="1040" b="0">
                           <a:solidFill>
                             <a:srgbClr val="333333"/>
                           </a:solidFill>
@@ -10901,7 +10901,7 @@
                         </a:defRPr>
                       </a:pPr>
                       <a:r>
-                        <a:rPr sz="1060" b="0">
+                        <a:rPr sz="1040" b="0">
                           <a:solidFill>
                             <a:srgbClr val="333333"/>
                           </a:solidFill>
@@ -10923,7 +10923,7 @@
                     <a:lstStyle/>
                     <a:p>
                       <a:pPr algn="l">
-                        <a:defRPr sz="1060" b="0">
+                        <a:defRPr sz="1040" b="0">
                           <a:solidFill>
                             <a:srgbClr val="333333"/>
                           </a:solidFill>
@@ -10931,13 +10931,13 @@
                         </a:defRPr>
                       </a:pPr>
                       <a:r>
-                        <a:rPr sz="1060" b="0">
+                        <a:rPr sz="1040" b="0">
                           <a:solidFill>
                             <a:srgbClr val="333333"/>
                           </a:solidFill>
                           <a:latin typeface="Segoe UI"/>
                         </a:rPr>
-                        <a:t>fill in live</a:t>
+                        <a:t>declined by the model</a:t>
                       </a:r>
                     </a:p>
                   </a:txBody>
@@ -10953,7 +10953,7 @@
                     <a:lstStyle/>
                     <a:p>
                       <a:pPr algn="l">
-                        <a:defRPr sz="1060" b="0">
+                        <a:defRPr sz="1040" b="0">
                           <a:solidFill>
                             <a:srgbClr val="333333"/>
                           </a:solidFill>
@@ -10961,13 +10961,13 @@
                         </a:defRPr>
                       </a:pPr>
                       <a:r>
-                        <a:rPr sz="1060" b="0">
+                        <a:rPr sz="1040" b="0">
                           <a:solidFill>
                             <a:srgbClr val="333333"/>
                           </a:solidFill>
                           <a:latin typeface="Segoe UI"/>
                         </a:rPr>
-                        <a:t>fill in live</a:t>
+                        <a:t>BLOCKED before the model</a:t>
                       </a:r>
                     </a:p>
                   </a:txBody>
@@ -10978,14 +10978,14 @@
                   </a:tcPr>
                 </a:tc>
               </a:tr>
-              <a:tr h="480060">
+              <a:tr h="394335">
                 <a:tc>
                   <a:txBody>
                     <a:bodyPr wrap="square"/>
                     <a:lstStyle/>
                     <a:p>
                       <a:pPr algn="l">
-                        <a:defRPr sz="1060" b="0">
+                        <a:defRPr sz="1040" b="0">
                           <a:solidFill>
                             <a:srgbClr val="333333"/>
                           </a:solidFill>
@@ -10993,7 +10993,7 @@
                         </a:defRPr>
                       </a:pPr>
                       <a:r>
-                        <a:rPr sz="1060" b="0">
+                        <a:rPr sz="1040" b="0">
                           <a:solidFill>
                             <a:srgbClr val="333333"/>
                           </a:solidFill>
@@ -11015,7 +11015,7 @@
                     <a:lstStyle/>
                     <a:p>
                       <a:pPr algn="l">
-                        <a:defRPr sz="1060" b="0">
+                        <a:defRPr sz="1040" b="0">
                           <a:solidFill>
                             <a:srgbClr val="333333"/>
                           </a:solidFill>
@@ -11023,7 +11023,7 @@
                         </a:defRPr>
                       </a:pPr>
                       <a:r>
-                        <a:rPr sz="1060" b="0">
+                        <a:rPr sz="1040" b="0">
                           <a:solidFill>
                             <a:srgbClr val="333333"/>
                           </a:solidFill>
@@ -11045,7 +11045,7 @@
                     <a:lstStyle/>
                     <a:p>
                       <a:pPr algn="l">
-                        <a:defRPr sz="1060" b="0">
+                        <a:defRPr sz="1040" b="0">
                           <a:solidFill>
                             <a:srgbClr val="333333"/>
                           </a:solidFill>
@@ -11053,13 +11053,13 @@
                         </a:defRPr>
                       </a:pPr>
                       <a:r>
-                        <a:rPr sz="1060" b="0">
+                        <a:rPr sz="1040" b="0">
                           <a:solidFill>
                             <a:srgbClr val="333333"/>
                           </a:solidFill>
                           <a:latin typeface="Segoe UI"/>
                         </a:rPr>
-                        <a:t>fill in live</a:t>
+                        <a:t>BLOCKED (jailbreak)</a:t>
                       </a:r>
                     </a:p>
                   </a:txBody>
@@ -11075,7 +11075,7 @@
                     <a:lstStyle/>
                     <a:p>
                       <a:pPr algn="l">
-                        <a:defRPr sz="1060" b="0">
+                        <a:defRPr sz="1040" b="0">
                           <a:solidFill>
                             <a:srgbClr val="333333"/>
                           </a:solidFill>
@@ -11083,13 +11083,13 @@
                         </a:defRPr>
                       </a:pPr>
                       <a:r>
-                        <a:rPr sz="1060" b="0">
+                        <a:rPr sz="1040" b="0">
                           <a:solidFill>
                             <a:srgbClr val="333333"/>
                           </a:solidFill>
                           <a:latin typeface="Segoe UI"/>
                         </a:rPr>
-                        <a:t>fill in live</a:t>
+                        <a:t>BLOCKED (jailbreak)</a:t>
                       </a:r>
                     </a:p>
                   </a:txBody>
@@ -11100,14 +11100,14 @@
                   </a:tcPr>
                 </a:tc>
               </a:tr>
-              <a:tr h="480060">
+              <a:tr h="394335">
                 <a:tc>
                   <a:txBody>
                     <a:bodyPr wrap="square"/>
                     <a:lstStyle/>
                     <a:p>
                       <a:pPr algn="l">
-                        <a:defRPr sz="1060" b="0">
+                        <a:defRPr sz="1040" b="0">
                           <a:solidFill>
                             <a:srgbClr val="333333"/>
                           </a:solidFill>
@@ -11115,7 +11115,7 @@
                         </a:defRPr>
                       </a:pPr>
                       <a:r>
-                        <a:rPr sz="1060" b="0">
+                        <a:rPr sz="1040" b="0">
                           <a:solidFill>
                             <a:srgbClr val="333333"/>
                           </a:solidFill>
@@ -11137,7 +11137,7 @@
                     <a:lstStyle/>
                     <a:p>
                       <a:pPr algn="l">
-                        <a:defRPr sz="1060" b="0">
+                        <a:defRPr sz="1040" b="0">
                           <a:solidFill>
                             <a:srgbClr val="333333"/>
                           </a:solidFill>
@@ -11145,7 +11145,7 @@
                         </a:defRPr>
                       </a:pPr>
                       <a:r>
-                        <a:rPr sz="1060" b="0">
+                        <a:rPr sz="1040" b="0">
                           <a:solidFill>
                             <a:srgbClr val="333333"/>
                           </a:solidFill>
@@ -11167,7 +11167,7 @@
                     <a:lstStyle/>
                     <a:p>
                       <a:pPr algn="l">
-                        <a:defRPr sz="1060" b="0">
+                        <a:defRPr sz="1040" b="0">
                           <a:solidFill>
                             <a:srgbClr val="333333"/>
                           </a:solidFill>
@@ -11175,13 +11175,13 @@
                         </a:defRPr>
                       </a:pPr>
                       <a:r>
-                        <a:rPr sz="1060" b="0">
+                        <a:rPr sz="1040" b="0">
                           <a:solidFill>
                             <a:srgbClr val="333333"/>
                           </a:solidFill>
                           <a:latin typeface="Segoe UI"/>
                         </a:rPr>
-                        <a:t>fill in live</a:t>
+                        <a:t>refused by the model</a:t>
                       </a:r>
                     </a:p>
                   </a:txBody>
@@ -11197,7 +11197,7 @@
                     <a:lstStyle/>
                     <a:p>
                       <a:pPr algn="l">
-                        <a:defRPr sz="1060" b="0">
+                        <a:defRPr sz="1040" b="0">
                           <a:solidFill>
                             <a:srgbClr val="333333"/>
                           </a:solidFill>
@@ -11205,13 +11205,13 @@
                         </a:defRPr>
                       </a:pPr>
                       <a:r>
-                        <a:rPr sz="1060" b="0">
+                        <a:rPr sz="1040" b="0">
                           <a:solidFill>
                             <a:srgbClr val="333333"/>
                           </a:solidFill>
                           <a:latin typeface="Segoe UI"/>
                         </a:rPr>
-                        <a:t>fill in live</a:t>
+                        <a:t>refused by the model</a:t>
                       </a:r>
                     </a:p>
                   </a:txBody>
@@ -11222,14 +11222,14 @@
                   </a:tcPr>
                 </a:tc>
               </a:tr>
-              <a:tr h="480060">
+              <a:tr h="394335">
                 <a:tc>
                   <a:txBody>
                     <a:bodyPr wrap="square"/>
                     <a:lstStyle/>
                     <a:p>
                       <a:pPr algn="l">
-                        <a:defRPr sz="1060" b="0">
+                        <a:defRPr sz="1040" b="0">
                           <a:solidFill>
                             <a:srgbClr val="333333"/>
                           </a:solidFill>
@@ -11237,13 +11237,13 @@
                         </a:defRPr>
                       </a:pPr>
                       <a:r>
-                        <a:rPr sz="1060" b="0">
+                        <a:rPr sz="1040" b="0">
                           <a:solidFill>
                             <a:srgbClr val="333333"/>
                           </a:solidFill>
                           <a:latin typeface="Segoe UI"/>
                         </a:rPr>
-                        <a:t>Benign control</a:t>
+                        <a:t>Skip meals (self-harm, Low)</a:t>
                       </a:r>
                     </a:p>
                   </a:txBody>
@@ -11259,7 +11259,7 @@
                     <a:lstStyle/>
                     <a:p>
                       <a:pPr algn="l">
-                        <a:defRPr sz="1060" b="0">
+                        <a:defRPr sz="1040" b="0">
                           <a:solidFill>
                             <a:srgbClr val="333333"/>
                           </a:solidFill>
@@ -11267,13 +11267,13 @@
                         </a:defRPr>
                       </a:pPr>
                       <a:r>
-                        <a:rPr sz="1060" b="0">
+                        <a:rPr sz="1040" b="0">
                           <a:solidFill>
                             <a:srgbClr val="333333"/>
                           </a:solidFill>
                           <a:latin typeface="Segoe UI"/>
                         </a:rPr>
-                        <a:t>none</a:t>
+                        <a:t>self-harm threshold Low</a:t>
                       </a:r>
                     </a:p>
                   </a:txBody>
@@ -11289,7 +11289,7 @@
                     <a:lstStyle/>
                     <a:p>
                       <a:pPr algn="l">
-                        <a:defRPr sz="1060" b="0">
+                        <a:defRPr sz="1040" b="0">
                           <a:solidFill>
                             <a:srgbClr val="333333"/>
                           </a:solidFill>
@@ -11297,13 +11297,13 @@
                         </a:defRPr>
                       </a:pPr>
                       <a:r>
-                        <a:rPr sz="1060" b="0">
+                        <a:rPr sz="1040" b="0">
                           <a:solidFill>
                             <a:srgbClr val="333333"/>
                           </a:solidFill>
                           <a:latin typeface="Segoe UI"/>
                         </a:rPr>
-                        <a:t>fill in live</a:t>
+                        <a:t>answered, annotated Low</a:t>
                       </a:r>
                     </a:p>
                   </a:txBody>
@@ -11319,7 +11319,7 @@
                     <a:lstStyle/>
                     <a:p>
                       <a:pPr algn="l">
-                        <a:defRPr sz="1060" b="0">
+                        <a:defRPr sz="1040" b="0">
                           <a:solidFill>
                             <a:srgbClr val="333333"/>
                           </a:solidFill>
@@ -11327,13 +11327,257 @@
                         </a:defRPr>
                       </a:pPr>
                       <a:r>
-                        <a:rPr sz="1060" b="0">
+                        <a:rPr sz="1040" b="0">
                           <a:solidFill>
                             <a:srgbClr val="333333"/>
                           </a:solidFill>
                           <a:latin typeface="Segoe UI"/>
                         </a:rPr>
-                        <a:t>fill in live</a:t>
+                        <a:t>BLOCKED (self-harm)</a:t>
+                      </a:r>
+                    </a:p>
+                  </a:txBody>
+                  <a:tcPr marL="36576" marR="36576" marT="18288" marB="18288" anchor="ctr">
+                    <a:solidFill>
+                      <a:srgbClr val="FFFFFF"/>
+                    </a:solidFill>
+                  </a:tcPr>
+                </a:tc>
+              </a:tr>
+              <a:tr h="394335">
+                <a:tc>
+                  <a:txBody>
+                    <a:bodyPr wrap="square"/>
+                    <a:lstStyle/>
+                    <a:p>
+                      <a:pPr algn="l">
+                        <a:defRPr sz="1040" b="0">
+                          <a:solidFill>
+                            <a:srgbClr val="333333"/>
+                          </a:solidFill>
+                          <a:latin typeface="Segoe UI"/>
+                        </a:defRPr>
+                      </a:pPr>
+                      <a:r>
+                        <a:rPr sz="1040" b="0">
+                          <a:solidFill>
+                            <a:srgbClr val="333333"/>
+                          </a:solidFill>
+                          <a:latin typeface="Segoe UI"/>
+                        </a:rPr>
+                        <a:t>Benign control</a:t>
+                      </a:r>
+                    </a:p>
+                  </a:txBody>
+                  <a:tcPr marL="36576" marR="36576" marT="18288" marB="18288" anchor="ctr">
+                    <a:solidFill>
+                      <a:srgbClr val="F7FAFC"/>
+                    </a:solidFill>
+                  </a:tcPr>
+                </a:tc>
+                <a:tc>
+                  <a:txBody>
+                    <a:bodyPr wrap="square"/>
+                    <a:lstStyle/>
+                    <a:p>
+                      <a:pPr algn="l">
+                        <a:defRPr sz="1040" b="0">
+                          <a:solidFill>
+                            <a:srgbClr val="333333"/>
+                          </a:solidFill>
+                          <a:latin typeface="Segoe UI"/>
+                        </a:defRPr>
+                      </a:pPr>
+                      <a:r>
+                        <a:rPr sz="1040" b="0">
+                          <a:solidFill>
+                            <a:srgbClr val="333333"/>
+                          </a:solidFill>
+                          <a:latin typeface="Segoe UI"/>
+                        </a:rPr>
+                        <a:t>none</a:t>
+                      </a:r>
+                    </a:p>
+                  </a:txBody>
+                  <a:tcPr marL="36576" marR="36576" marT="18288" marB="18288" anchor="ctr">
+                    <a:solidFill>
+                      <a:srgbClr val="F7FAFC"/>
+                    </a:solidFill>
+                  </a:tcPr>
+                </a:tc>
+                <a:tc>
+                  <a:txBody>
+                    <a:bodyPr wrap="square"/>
+                    <a:lstStyle/>
+                    <a:p>
+                      <a:pPr algn="l">
+                        <a:defRPr sz="1040" b="0">
+                          <a:solidFill>
+                            <a:srgbClr val="333333"/>
+                          </a:solidFill>
+                          <a:latin typeface="Segoe UI"/>
+                        </a:defRPr>
+                      </a:pPr>
+                      <a:r>
+                        <a:rPr sz="1040" b="0">
+                          <a:solidFill>
+                            <a:srgbClr val="333333"/>
+                          </a:solidFill>
+                          <a:latin typeface="Segoe UI"/>
+                        </a:rPr>
+                        <a:t>answered</a:t>
+                      </a:r>
+                    </a:p>
+                  </a:txBody>
+                  <a:tcPr marL="36576" marR="36576" marT="18288" marB="18288" anchor="ctr">
+                    <a:solidFill>
+                      <a:srgbClr val="F7FAFC"/>
+                    </a:solidFill>
+                  </a:tcPr>
+                </a:tc>
+                <a:tc>
+                  <a:txBody>
+                    <a:bodyPr wrap="square"/>
+                    <a:lstStyle/>
+                    <a:p>
+                      <a:pPr algn="l">
+                        <a:defRPr sz="1040" b="0">
+                          <a:solidFill>
+                            <a:srgbClr val="333333"/>
+                          </a:solidFill>
+                          <a:latin typeface="Segoe UI"/>
+                        </a:defRPr>
+                      </a:pPr>
+                      <a:r>
+                        <a:rPr sz="1040" b="0">
+                          <a:solidFill>
+                            <a:srgbClr val="333333"/>
+                          </a:solidFill>
+                          <a:latin typeface="Segoe UI"/>
+                        </a:rPr>
+                        <a:t>answered</a:t>
+                      </a:r>
+                    </a:p>
+                  </a:txBody>
+                  <a:tcPr marL="36576" marR="36576" marT="18288" marB="18288" anchor="ctr">
+                    <a:solidFill>
+                      <a:srgbClr val="F7FAFC"/>
+                    </a:solidFill>
+                  </a:tcPr>
+                </a:tc>
+              </a:tr>
+              <a:tr h="394335">
+                <a:tc>
+                  <a:txBody>
+                    <a:bodyPr wrap="square"/>
+                    <a:lstStyle/>
+                    <a:p>
+                      <a:pPr algn="l">
+                        <a:defRPr sz="1040" b="0">
+                          <a:solidFill>
+                            <a:srgbClr val="333333"/>
+                          </a:solidFill>
+                          <a:latin typeface="Segoe UI"/>
+                        </a:defRPr>
+                      </a:pPr>
+                      <a:r>
+                        <a:rPr sz="1040" b="0">
+                          <a:solidFill>
+                            <a:srgbClr val="333333"/>
+                          </a:solidFill>
+                          <a:latin typeface="Segoe UI"/>
+                        </a:rPr>
+                        <a:t>Benign dose reminder</a:t>
+                      </a:r>
+                    </a:p>
+                  </a:txBody>
+                  <a:tcPr marL="36576" marR="36576" marT="18288" marB="18288" anchor="ctr">
+                    <a:solidFill>
+                      <a:srgbClr val="FFFFFF"/>
+                    </a:solidFill>
+                  </a:tcPr>
+                </a:tc>
+                <a:tc>
+                  <a:txBody>
+                    <a:bodyPr wrap="square"/>
+                    <a:lstStyle/>
+                    <a:p>
+                      <a:pPr algn="l">
+                        <a:defRPr sz="1040" b="0">
+                          <a:solidFill>
+                            <a:srgbClr val="333333"/>
+                          </a:solidFill>
+                          <a:latin typeface="Segoe UI"/>
+                        </a:defRPr>
+                      </a:pPr>
+                      <a:r>
+                        <a:rPr sz="1040" b="0">
+                          <a:solidFill>
+                            <a:srgbClr val="333333"/>
+                          </a:solidFill>
+                          <a:latin typeface="Segoe UI"/>
+                        </a:rPr>
+                        <a:t>blocklist livewell-medication-dosage</a:t>
+                      </a:r>
+                    </a:p>
+                  </a:txBody>
+                  <a:tcPr marL="36576" marR="36576" marT="18288" marB="18288" anchor="ctr">
+                    <a:solidFill>
+                      <a:srgbClr val="FFFFFF"/>
+                    </a:solidFill>
+                  </a:tcPr>
+                </a:tc>
+                <a:tc>
+                  <a:txBody>
+                    <a:bodyPr wrap="square"/>
+                    <a:lstStyle/>
+                    <a:p>
+                      <a:pPr algn="l">
+                        <a:defRPr sz="1040" b="0">
+                          <a:solidFill>
+                            <a:srgbClr val="333333"/>
+                          </a:solidFill>
+                          <a:latin typeface="Segoe UI"/>
+                        </a:defRPr>
+                      </a:pPr>
+                      <a:r>
+                        <a:rPr sz="1040" b="0">
+                          <a:solidFill>
+                            <a:srgbClr val="333333"/>
+                          </a:solidFill>
+                          <a:latin typeface="Segoe UI"/>
+                        </a:rPr>
+                        <a:t>answered</a:t>
+                      </a:r>
+                    </a:p>
+                  </a:txBody>
+                  <a:tcPr marL="36576" marR="36576" marT="18288" marB="18288" anchor="ctr">
+                    <a:solidFill>
+                      <a:srgbClr val="FFFFFF"/>
+                    </a:solidFill>
+                  </a:tcPr>
+                </a:tc>
+                <a:tc>
+                  <a:txBody>
+                    <a:bodyPr wrap="square"/>
+                    <a:lstStyle/>
+                    <a:p>
+                      <a:pPr algn="l">
+                        <a:defRPr sz="1040" b="0">
+                          <a:solidFill>
+                            <a:srgbClr val="333333"/>
+                          </a:solidFill>
+                          <a:latin typeface="Segoe UI"/>
+                        </a:defRPr>
+                      </a:pPr>
+                      <a:r>
+                        <a:rPr sz="1040" b="0">
+                          <a:solidFill>
+                            <a:srgbClr val="333333"/>
+                          </a:solidFill>
+                          <a:latin typeface="Segoe UI"/>
+                        </a:rPr>
+                        <a:t>BLOCKED: false positive</a:t>
                       </a:r>
                     </a:p>
                   </a:txBody>
@@ -11356,8 +11600,89 @@
         </p:nvSpPr>
         <p:spPr>
           <a:xfrm>
-            <a:off x="685800" y="4160520"/>
-            <a:ext cx="5303520" cy="1417320"/>
+            <a:off x="685800" y="4389120"/>
+            <a:ext cx="3520440" cy="1417320"/>
+          </a:xfrm>
+          <a:prstGeom prst="roundRect">
+            <a:avLst/>
+          </a:prstGeom>
+          <a:solidFill>
+            <a:srgbClr val="FFFFFF"/>
+          </a:solidFill>
+          <a:ln w="12700">
+            <a:solidFill>
+              <a:srgbClr val="0B2E59"/>
+            </a:solidFill>
+          </a:ln>
+        </p:spPr>
+        <p:style>
+          <a:lnRef idx="1">
+            <a:schemeClr val="accent1"/>
+          </a:lnRef>
+          <a:fillRef idx="3">
+            <a:schemeClr val="accent1"/>
+          </a:fillRef>
+          <a:effectRef idx="2">
+            <a:schemeClr val="accent1"/>
+          </a:effectRef>
+          <a:fontRef idx="minor">
+            <a:schemeClr val="lt1"/>
+          </a:fontRef>
+        </p:style>
+        <p:txBody>
+          <a:bodyPr rtlCol="0" anchor="ctr" wrap="square" lIns="73152" rIns="73152" bIns="36576"/>
+          <a:lstStyle/>
+          <a:p>
+            <a:pPr algn="ctr">
+              <a:defRPr sz="1150" b="1">
+                <a:solidFill>
+                  <a:srgbClr val="0B2E59"/>
+                </a:solidFill>
+                <a:latin typeface="Segoe UI"/>
+              </a:defRPr>
+            </a:pPr>
+            <a:r>
+              <a:t>Block vs annotate</a:t>
+            </a:r>
+          </a:p>
+          <a:p>
+            <a:pPr algn="ctr">
+              <a:defRPr sz="1150" b="1">
+                <a:solidFill>
+                  <a:srgbClr val="0B2E59"/>
+                </a:solidFill>
+                <a:latin typeface="Segoe UI"/>
+              </a:defRPr>
+            </a:pPr>
+            <a:r>
+              <a:t>At the threshold: blocked, HTTP 400, Failed trace.</a:t>
+            </a:r>
+          </a:p>
+          <a:p>
+            <a:pPr algn="ctr">
+              <a:defRPr sz="1150" b="1">
+                <a:solidFill>
+                  <a:srgbClr val="0B2E59"/>
+                </a:solidFill>
+                <a:latin typeface="Segoe UI"/>
+              </a:defRPr>
+            </a:pPr>
+            <a:r>
+              <a:t>Below it: answered, severity recorded.</a:t>
+            </a:r>
+          </a:p>
+        </p:txBody>
+      </p:sp>
+      <p:sp>
+        <p:nvSpPr>
+          <p:cNvPr id="9" name="Rounded Rectangle 8"/>
+          <p:cNvSpPr/>
+          <p:nvPr/>
+        </p:nvSpPr>
+        <p:spPr>
+          <a:xfrm>
+            <a:off x="4434840" y="4389120"/>
+            <a:ext cx="3749039" cy="1417320"/>
           </a:xfrm>
           <a:prstGeom prst="roundRect">
             <a:avLst/>
@@ -11390,7 +11715,7 @@
           <a:lstStyle/>
           <a:p>
             <a:pPr algn="ctr">
-              <a:defRPr sz="1270" b="1">
+              <a:defRPr sz="1150" b="1">
                 <a:solidFill>
                   <a:srgbClr val="0B2E59"/>
                 </a:solidFill>
@@ -11403,7 +11728,7 @@
           </a:p>
           <a:p>
             <a:pPr algn="ctr">
-              <a:defRPr sz="1270" b="1">
+              <a:defRPr sz="1150" b="1">
                 <a:solidFill>
                   <a:srgbClr val="0B2E59"/>
                 </a:solidFill>
@@ -11418,14 +11743,14 @@
       </p:sp>
       <p:sp>
         <p:nvSpPr>
-          <p:cNvPr id="9" name="Rounded Rectangle 8"/>
+          <p:cNvPr id="10" name="Rounded Rectangle 9"/>
           <p:cNvSpPr/>
           <p:nvPr/>
         </p:nvSpPr>
         <p:spPr>
           <a:xfrm>
-            <a:off x="6355080" y="4160520"/>
-            <a:ext cx="4937760" cy="1417320"/>
+            <a:off x="8412480" y="4389120"/>
+            <a:ext cx="3108960" cy="1417320"/>
           </a:xfrm>
           <a:prstGeom prst="roundRect">
             <a:avLst/>
@@ -11458,7 +11783,7 @@
           <a:lstStyle/>
           <a:p>
             <a:pPr algn="ctr">
-              <a:defRPr sz="1500" b="1">
+              <a:defRPr sz="1300" b="1">
                 <a:solidFill>
                   <a:srgbClr val="0B2E59"/>
                 </a:solidFill>
@@ -11471,7 +11796,7 @@
           </a:p>
           <a:p>
             <a:pPr algn="ctr">
-              <a:defRPr sz="1500" b="1">
+              <a:defRPr sz="1300" b="1">
                 <a:solidFill>
                   <a:srgbClr val="0B2E59"/>
                 </a:solidFill>
@@ -11484,7 +11809,7 @@
           </a:p>
           <a:p>
             <a:pPr algn="ctr">
-              <a:defRPr sz="1500" b="1">
+              <a:defRPr sz="1300" b="1">
                 <a:solidFill>
                   <a:srgbClr val="0B2E59"/>
                 </a:solidFill>
@@ -12762,7 +13087,7 @@
               </a:defRPr>
             </a:pPr>
             <a:r>
-              <a:t>approx. US$0.36/h; approx. US$259/month if left on</a:t>
+              <a:t>approx. US$0.36/h; approx. US$259/month if left on; F4 doubles it</a:t>
             </a:r>
           </a:p>
         </p:txBody>
@@ -13996,7 +14321,7 @@
                           </a:solidFill>
                           <a:latin typeface="Segoe UI"/>
                         </a:rPr>
-                        <a:t>Compare model-router vs gpt-4.1-mini; read router pick in trace</a:t>
+                        <a:t>Compare model-router vs gpt-4.1-mini; read the router's pick in the model-router playground</a:t>
                       </a:r>
                     </a:p>
                   </a:txBody>
@@ -18019,8 +18344,8 @@
         </p:nvSpPr>
         <p:spPr>
           <a:xfrm>
-            <a:off x="502920" y="1828800"/>
-            <a:ext cx="2057400" cy="1234440"/>
+            <a:off x="502920" y="1691640"/>
+            <a:ext cx="2057400" cy="777240"/>
           </a:xfrm>
           <a:prstGeom prst="chevron">
             <a:avLst/>
@@ -18053,7 +18378,7 @@
           <a:lstStyle/>
           <a:p>
             <a:pPr algn="ctr">
-              <a:defRPr sz="1300" b="1">
+              <a:defRPr sz="1500" b="1">
                 <a:solidFill>
                   <a:srgbClr val="0B2E59"/>
                 </a:solidFill>
@@ -18064,11 +18389,34 @@
               <a:t>Unify</a:t>
             </a:r>
           </a:p>
+        </p:txBody>
+      </p:sp>
+      <p:sp>
+        <p:nvSpPr>
+          <p:cNvPr id="8" name="TextBox 7"/>
+          <p:cNvSpPr txBox="1"/>
+          <p:nvPr/>
+        </p:nvSpPr>
+        <p:spPr>
+          <a:xfrm>
+            <a:off x="594360" y="2606040"/>
+            <a:ext cx="1874519" cy="1005840"/>
+          </a:xfrm>
+          <a:prstGeom prst="rect">
+            <a:avLst/>
+          </a:prstGeom>
+          <a:noFill/>
+        </p:spPr>
+        <p:txBody>
+          <a:bodyPr wrap="square" lIns="73152" rIns="73152" bIns="36576" anchor="t">
+            <a:spAutoFit/>
+          </a:bodyPr>
+          <a:lstStyle/>
           <a:p>
             <a:pPr algn="ctr">
-              <a:defRPr sz="1300" b="1">
-                <a:solidFill>
-                  <a:srgbClr val="0B2E59"/>
+              <a:defRPr sz="1250" b="0">
+                <a:solidFill>
+                  <a:srgbClr val="333333"/>
                 </a:solidFill>
                 <a:latin typeface="Segoe UI"/>
               </a:defRPr>
@@ -18081,14 +18429,14 @@
       </p:sp>
       <p:sp>
         <p:nvSpPr>
-          <p:cNvPr id="8" name="Chevron 7"/>
+          <p:cNvPr id="9" name="Chevron 8"/>
           <p:cNvSpPr/>
           <p:nvPr/>
         </p:nvSpPr>
         <p:spPr>
           <a:xfrm>
-            <a:off x="2743200" y="1828800"/>
-            <a:ext cx="2057400" cy="1234440"/>
+            <a:off x="2743200" y="1691640"/>
+            <a:ext cx="2057400" cy="777240"/>
           </a:xfrm>
           <a:prstGeom prst="chevron">
             <a:avLst/>
@@ -18121,7 +18469,7 @@
           <a:lstStyle/>
           <a:p>
             <a:pPr algn="ctr">
-              <a:defRPr sz="1300" b="1">
+              <a:defRPr sz="1500" b="1">
                 <a:solidFill>
                   <a:srgbClr val="0B2E59"/>
                 </a:solidFill>
@@ -18132,11 +18480,34 @@
               <a:t>Govern</a:t>
             </a:r>
           </a:p>
+        </p:txBody>
+      </p:sp>
+      <p:sp>
+        <p:nvSpPr>
+          <p:cNvPr id="10" name="TextBox 9"/>
+          <p:cNvSpPr txBox="1"/>
+          <p:nvPr/>
+        </p:nvSpPr>
+        <p:spPr>
+          <a:xfrm>
+            <a:off x="2834640" y="2606040"/>
+            <a:ext cx="1874519" cy="1005840"/>
+          </a:xfrm>
+          <a:prstGeom prst="rect">
+            <a:avLst/>
+          </a:prstGeom>
+          <a:noFill/>
+        </p:spPr>
+        <p:txBody>
+          <a:bodyPr wrap="square" lIns="73152" rIns="73152" bIns="36576" anchor="t">
+            <a:spAutoFit/>
+          </a:bodyPr>
+          <a:lstStyle/>
           <a:p>
             <a:pPr algn="ctr">
-              <a:defRPr sz="1300" b="1">
-                <a:solidFill>
-                  <a:srgbClr val="0B2E59"/>
+              <a:defRPr sz="1250" b="0">
+                <a:solidFill>
+                  <a:srgbClr val="333333"/>
                 </a:solidFill>
                 <a:latin typeface="Segoe UI"/>
               </a:defRPr>
@@ -18149,14 +18520,14 @@
       </p:sp>
       <p:sp>
         <p:nvSpPr>
-          <p:cNvPr id="9" name="Chevron 8"/>
+          <p:cNvPr id="11" name="Chevron 10"/>
           <p:cNvSpPr/>
           <p:nvPr/>
         </p:nvSpPr>
         <p:spPr>
           <a:xfrm>
-            <a:off x="4983480" y="1828800"/>
-            <a:ext cx="2057400" cy="1234440"/>
+            <a:off x="4983480" y="1691640"/>
+            <a:ext cx="2057400" cy="777240"/>
           </a:xfrm>
           <a:prstGeom prst="chevron">
             <a:avLst/>
@@ -18189,7 +18560,7 @@
           <a:lstStyle/>
           <a:p>
             <a:pPr algn="ctr">
-              <a:defRPr sz="1300" b="1">
+              <a:defRPr sz="1500" b="1">
                 <a:solidFill>
                   <a:srgbClr val="0B2E59"/>
                 </a:solidFill>
@@ -18200,11 +18571,34 @@
               <a:t>Personalise</a:t>
             </a:r>
           </a:p>
+        </p:txBody>
+      </p:sp>
+      <p:sp>
+        <p:nvSpPr>
+          <p:cNvPr id="12" name="TextBox 11"/>
+          <p:cNvSpPr txBox="1"/>
+          <p:nvPr/>
+        </p:nvSpPr>
+        <p:spPr>
+          <a:xfrm>
+            <a:off x="5074920" y="2606040"/>
+            <a:ext cx="1874519" cy="1005840"/>
+          </a:xfrm>
+          <a:prstGeom prst="rect">
+            <a:avLst/>
+          </a:prstGeom>
+          <a:noFill/>
+        </p:spPr>
+        <p:txBody>
+          <a:bodyPr wrap="square" lIns="73152" rIns="73152" bIns="36576" anchor="t">
+            <a:spAutoFit/>
+          </a:bodyPr>
+          <a:lstStyle/>
           <a:p>
             <a:pPr algn="ctr">
-              <a:defRPr sz="1300" b="1">
-                <a:solidFill>
-                  <a:srgbClr val="0B2E59"/>
+              <a:defRPr sz="1250" b="0">
+                <a:solidFill>
+                  <a:srgbClr val="333333"/>
                 </a:solidFill>
                 <a:latin typeface="Segoe UI"/>
               </a:defRPr>
@@ -18217,14 +18611,14 @@
       </p:sp>
       <p:sp>
         <p:nvSpPr>
-          <p:cNvPr id="10" name="Chevron 9"/>
+          <p:cNvPr id="13" name="Chevron 12"/>
           <p:cNvSpPr/>
           <p:nvPr/>
         </p:nvSpPr>
         <p:spPr>
           <a:xfrm>
-            <a:off x="7223760" y="1828800"/>
-            <a:ext cx="2057400" cy="1234440"/>
+            <a:off x="7223760" y="1691640"/>
+            <a:ext cx="2057400" cy="777240"/>
           </a:xfrm>
           <a:prstGeom prst="chevron">
             <a:avLst/>
@@ -18257,7 +18651,7 @@
           <a:lstStyle/>
           <a:p>
             <a:pPr algn="ctr">
-              <a:defRPr sz="1300" b="1">
+              <a:defRPr sz="1500" b="1">
                 <a:solidFill>
                   <a:srgbClr val="0B2E59"/>
                 </a:solidFill>
@@ -18268,11 +18662,34 @@
               <a:t>Converse</a:t>
             </a:r>
           </a:p>
+        </p:txBody>
+      </p:sp>
+      <p:sp>
+        <p:nvSpPr>
+          <p:cNvPr id="14" name="TextBox 13"/>
+          <p:cNvSpPr txBox="1"/>
+          <p:nvPr/>
+        </p:nvSpPr>
+        <p:spPr>
+          <a:xfrm>
+            <a:off x="7315200" y="2606040"/>
+            <a:ext cx="1874519" cy="1005840"/>
+          </a:xfrm>
+          <a:prstGeom prst="rect">
+            <a:avLst/>
+          </a:prstGeom>
+          <a:noFill/>
+        </p:spPr>
+        <p:txBody>
+          <a:bodyPr wrap="square" lIns="73152" rIns="73152" bIns="36576" anchor="t">
+            <a:spAutoFit/>
+          </a:bodyPr>
+          <a:lstStyle/>
           <a:p>
             <a:pPr algn="ctr">
-              <a:defRPr sz="1300" b="1">
-                <a:solidFill>
-                  <a:srgbClr val="0B2E59"/>
+              <a:defRPr sz="1250" b="0">
+                <a:solidFill>
+                  <a:srgbClr val="333333"/>
                 </a:solidFill>
                 <a:latin typeface="Segoe UI"/>
               </a:defRPr>
@@ -18285,14 +18702,14 @@
       </p:sp>
       <p:sp>
         <p:nvSpPr>
-          <p:cNvPr id="11" name="Chevron 10"/>
+          <p:cNvPr id="15" name="Chevron 14"/>
           <p:cNvSpPr/>
           <p:nvPr/>
         </p:nvSpPr>
         <p:spPr>
           <a:xfrm>
-            <a:off x="9464040" y="1828800"/>
-            <a:ext cx="2057400" cy="1234440"/>
+            <a:off x="9464040" y="1691640"/>
+            <a:ext cx="2057400" cy="777240"/>
           </a:xfrm>
           <a:prstGeom prst="chevron">
             <a:avLst/>
@@ -18325,7 +18742,7 @@
           <a:lstStyle/>
           <a:p>
             <a:pPr algn="ctr">
-              <a:defRPr sz="1300" b="1">
+              <a:defRPr sz="1500" b="1">
                 <a:solidFill>
                   <a:srgbClr val="FFFFFF"/>
                 </a:solidFill>
@@ -18336,31 +18753,18 @@
               <a:t>Coach &amp; Act</a:t>
             </a:r>
           </a:p>
-          <a:p>
-            <a:pPr algn="ctr">
-              <a:defRPr sz="1300" b="1">
-                <a:solidFill>
-                  <a:srgbClr val="FFFFFF"/>
-                </a:solidFill>
-                <a:latin typeface="Segoe UI"/>
-              </a:defRPr>
-            </a:pPr>
-            <a:r>
-              <a:t>Foundry agent talks to Rahim and takes approved action</a:t>
-            </a:r>
-          </a:p>
-        </p:txBody>
-      </p:sp>
-      <p:sp>
-        <p:nvSpPr>
-          <p:cNvPr id="12" name="TextBox 11"/>
+        </p:txBody>
+      </p:sp>
+      <p:sp>
+        <p:nvSpPr>
+          <p:cNvPr id="16" name="TextBox 15"/>
           <p:cNvSpPr txBox="1"/>
           <p:nvPr/>
         </p:nvSpPr>
         <p:spPr>
           <a:xfrm>
-            <a:off x="713232" y="1078992"/>
-            <a:ext cx="5577840" cy="320040"/>
+            <a:off x="9555480" y="2606040"/>
+            <a:ext cx="1874519" cy="1005840"/>
           </a:xfrm>
           <a:prstGeom prst="rect">
             <a:avLst/>
@@ -18373,30 +18777,30 @@
           </a:bodyPr>
           <a:lstStyle/>
           <a:p>
-            <a:pPr algn="l">
-              <a:defRPr sz="1600" b="1">
-                <a:solidFill>
-                  <a:srgbClr val="333333"/>
-                </a:solidFill>
-                <a:latin typeface="Segoe UI"/>
-              </a:defRPr>
-            </a:pPr>
-            <a:r>
-              <a:t>Fabric workshop: Resident 360 sees Rahim</a:t>
-            </a:r>
-          </a:p>
-        </p:txBody>
-      </p:sp>
-      <p:sp>
-        <p:nvSpPr>
-          <p:cNvPr id="13" name="TextBox 12"/>
+            <a:pPr algn="ctr">
+              <a:defRPr sz="1250" b="1">
+                <a:solidFill>
+                  <a:srgbClr val="0F7C8C"/>
+                </a:solidFill>
+                <a:latin typeface="Segoe UI"/>
+              </a:defRPr>
+            </a:pPr>
+            <a:r>
+              <a:t>Foundry agent talks to Rahim and takes approved action</a:t>
+            </a:r>
+          </a:p>
+        </p:txBody>
+      </p:sp>
+      <p:sp>
+        <p:nvSpPr>
+          <p:cNvPr id="17" name="TextBox 16"/>
           <p:cNvSpPr txBox="1"/>
           <p:nvPr/>
         </p:nvSpPr>
         <p:spPr>
           <a:xfrm>
-            <a:off x="7315200" y="1078992"/>
-            <a:ext cx="4114800" cy="320040"/>
+            <a:off x="713232" y="1078992"/>
+            <a:ext cx="5577840" cy="320040"/>
           </a:xfrm>
           <a:prstGeom prst="rect">
             <a:avLst/>
@@ -18412,6 +18816,42 @@
             <a:pPr algn="l">
               <a:defRPr sz="1600" b="1">
                 <a:solidFill>
+                  <a:srgbClr val="333333"/>
+                </a:solidFill>
+                <a:latin typeface="Segoe UI"/>
+              </a:defRPr>
+            </a:pPr>
+            <a:r>
+              <a:t>Fabric workshop: Resident 360 sees Rahim</a:t>
+            </a:r>
+          </a:p>
+        </p:txBody>
+      </p:sp>
+      <p:sp>
+        <p:nvSpPr>
+          <p:cNvPr id="18" name="TextBox 17"/>
+          <p:cNvSpPr txBox="1"/>
+          <p:nvPr/>
+        </p:nvSpPr>
+        <p:spPr>
+          <a:xfrm>
+            <a:off x="7315200" y="1078992"/>
+            <a:ext cx="4114800" cy="320040"/>
+          </a:xfrm>
+          <a:prstGeom prst="rect">
+            <a:avLst/>
+          </a:prstGeom>
+          <a:noFill/>
+        </p:spPr>
+        <p:txBody>
+          <a:bodyPr wrap="square" lIns="73152" rIns="73152" bIns="36576" anchor="t">
+            <a:spAutoFit/>
+          </a:bodyPr>
+          <a:lstStyle/>
+          <a:p>
+            <a:pPr algn="l">
+              <a:defRPr sz="1600" b="1">
+                <a:solidFill>
                   <a:srgbClr val="0F7C8C"/>
                 </a:solidFill>
                 <a:latin typeface="Segoe UI"/>
@@ -18425,7 +18865,7 @@
       </p:sp>
       <p:sp>
         <p:nvSpPr>
-          <p:cNvPr id="14" name="Rounded Rectangle 13"/>
+          <p:cNvPr id="19" name="Rounded Rectangle 18"/>
           <p:cNvSpPr/>
           <p:nvPr/>
         </p:nvSpPr>
@@ -18745,7 +19185,7 @@
               </a:defRPr>
             </a:pPr>
             <a:r>
-              <a:t>Foundry IQ + profile + memory; never Fabric</a:t>
+              <a:t>Foundry IQ + profile + memory; Fabric once, age band only</a:t>
             </a:r>
           </a:p>
         </p:txBody>
@@ -19290,7 +19730,7 @@
                           </a:solidFill>
                           <a:latin typeface="Segoe UI"/>
                         </a:rPr>
-                        <a:t>Rahim asks for hazy-day indoor activities; Mei asks the aggregate region question via Fabric.</a:t>
+                        <a:t>Rahim gets hazy-day activities with approval, then asks which programme people his age stick with (one age-band Fabric question); Mei asks the region question.</a:t>
                       </a:r>
                     </a:p>
                   </a:txBody>
@@ -19474,7 +19914,7 @@
                           </a:solidFill>
                           <a:latin typeface="Segoe UI"/>
                         </a:rPr>
-                        <a:t>The bridge closes on multi-hop aggregate reasoning and why Fabric IQ is for officer questions.</a:t>
+                        <a:t>The bridge closes on multi-hop aggregate reasoning and why Fabric IQ only ever receives aggregate questions.</a:t>
                       </a:r>
                     </a:p>
                   </a:txBody>
@@ -19539,7 +19979,7 @@
               </a:defRPr>
             </a:pPr>
             <a:r>
-              <a:t>Routing rule: citizen questions stay with Foundry IQ, profile tools and memory; officer aggregate questions may call Fabric.</a:t>
+              <a:t>Routing rule: guidance stays with Foundry IQ, profile and memory; only aggregate questions (cohort, region, programme) go to Fabric.</a:t>
             </a:r>
           </a:p>
         </p:txBody>
@@ -20131,7 +20571,7 @@
               </a:defRPr>
             </a:pPr>
             <a:r>
-              <a:t>get_citizen_profile</a:t>
+              <a:t>livewell_profile</a:t>
             </a:r>
           </a:p>
           <a:p>
@@ -20144,7 +20584,7 @@
               </a:defRPr>
             </a:pPr>
             <a:r>
-              <a:t>resident_360 extract</a:t>
+              <a:t>resident profile extract</a:t>
             </a:r>
           </a:p>
         </p:txBody>
@@ -20510,7 +20950,7 @@
               </a:defRPr>
             </a:pPr>
             <a:r>
-              <a:t>Fabric F2</a:t>
+              <a:t>Fabric F2 / F4</a:t>
             </a:r>
           </a:p>
           <a:p>
@@ -22172,7 +22612,7 @@
               </a:defRPr>
             </a:pPr>
             <a:r>
-              <a:t>Agent introduces itself, states it is not a doctor, and refuses to diagnose.</a:t>
+              <a:t>Agent introduces itself, says it is not a doctor and refuses to diagnose; the model-router playground shows which model it picked.</a:t>
             </a:r>
           </a:p>
         </p:txBody>
@@ -22956,7 +23396,7 @@
               </a:defRPr>
             </a:pPr>
             <a:r>
-              <a:t>Pre-diabetes food question cites at least one KB document and invents no source.</a:t>
+              <a:t>Pre-diabetes food question cites at least one KB document; the supplement question routes to a clinician with no invented source.</a:t>
             </a:r>
           </a:p>
         </p:txBody>

</xml_diff>

<commit_message>
Add lab-flow participant deck and refresh Day 1 deck (#11)
New deck/build_lab_flow.py builds LiveWell-Lab-Flow.pptx (18 slides): journey, layer staircase, two seats, lab-page anatomy, one slide per lab with screenshots, guardrail ladder, orchestration lanes, objectives, patterns, resources and takeaways. Day 1 deck module cards, guardrail ladder, Fabric step objective and chevrons updated to match the current labs.

Co-authored-by: tonirex <tonirex@github.com>
Co-authored-by: Copilot App <223556219+Copilot@users.noreply.github.com>
</commit_message>
<xml_diff>
--- a/deck/LiveWell-Foundry-Workshop-Day1.pptx
+++ b/deck/LiveWell-Foundry-Workshop-Day1.pptx
@@ -591,7 +591,7 @@
           <a:lstStyle/>
           <a:p>
             <a:r>
-              <a:t>Frame this module by capability first and story second. Emphasise the checkpoint because it is the gate to move on from Lab 2. For mixed-skill groups, point Navigator participants to the portal path and Builder participants to the Python script path. Gate: continue only when the stated checkpoint evidence is visible or the facilitator chooses the backup path.</a:t>
+              <a:t>Frame this module by capability first and story second. Close Lab 2 on the checkpoint: participants compare their result with the collapsed Expected output on the lab page; nothing is submitted. For mixed-skill groups, point Navigator participants to the portal path and Builder participants to the Python script path. Move on when most of the room sees the expected result, or show the facilitator's demo agent as the backup path.</a:t>
             </a:r>
           </a:p>
         </p:txBody>
@@ -661,7 +661,7 @@
           <a:lstStyle/>
           <a:p>
             <a:r>
-              <a:t>Frame this module by capability first and story second. Emphasise the checkpoint because it is the gate to move on from Lab 3. For mixed-skill groups, point Navigator participants to the portal path and Builder participants to the Python script path. Gate: continue only when the stated checkpoint evidence is visible or the facilitator chooses the backup path.</a:t>
+              <a:t>Frame this module by capability first and story second. Close Lab 3 on the checkpoint: participants compare their result with the collapsed Expected output on the lab page; nothing is submitted. For mixed-skill groups, point Navigator participants to the portal path and Builder participants to the Python script path. Move on when most of the room sees the expected result, or show the facilitator's demo agent as the backup path.</a:t>
             </a:r>
           </a:p>
         </p:txBody>
@@ -731,7 +731,7 @@
           <a:lstStyle/>
           <a:p>
             <a:r>
-              <a:t>Frame this module by capability first and story second. Emphasise the checkpoint because it is the gate to move on from Fabric step. For mixed-skill groups, point Navigator participants to the portal path and Builder participants to the Python script path. Gate: continue only when the stated checkpoint evidence is visible or the facilitator chooses the backup path.</a:t>
+              <a:t>Frame this module by capability first and story second. Close Fabric step on the checkpoint: participants compare their result with the collapsed Expected output on the lab page; nothing is submitted. For mixed-skill groups, point Navigator participants to the portal path and Builder participants to the Python script path. Move on when most of the room sees the expected result, or show the facilitator's demo agent as the backup path.</a:t>
             </a:r>
           </a:p>
         </p:txBody>
@@ -801,7 +801,7 @@
           <a:lstStyle/>
           <a:p>
             <a:r>
-              <a:t>Frame this module by capability first and story second. Emphasise the checkpoint because it is the gate to move on from Lab 4. For mixed-skill groups, point Navigator participants to the portal path and Builder participants to the Python script path. Gate: continue only when the stated checkpoint evidence is visible or the facilitator chooses the backup path.</a:t>
+              <a:t>Frame this module by capability first and story second. Close Lab 4 on the checkpoint: participants compare their result with the collapsed Expected output on the lab page; nothing is submitted. For mixed-skill groups, point Navigator participants to the portal path and Builder participants to the Python script path. Move on when most of the room sees the expected result, or show the facilitator's demo agent as the backup path.</a:t>
             </a:r>
           </a:p>
         </p:txBody>
@@ -941,7 +941,7 @@
           <a:lstStyle/>
           <a:p>
             <a:r>
-              <a:t>Do not present these as competing products. Foundry IQ is the document and knowledge grounding path for the coach; Fabric IQ is the governed business data path for the officer. Use the examples row to reinforce why Rahim stays out of Fabric and Mei Lin can use it. Gate: move on when participants can choose the correct IQ for a new prompt.</a:t>
+              <a:t>Do not present these as competing products. Foundry IQ is the document and knowledge grounding path for the coach; Fabric IQ is the governed business data path for the officer. Use the examples row to show that Rahim's guidance stays in Foundry IQ; Fabric only answers aggregate questions, from Mei Lin or from Rahim's one age-band cohort question. Gate: move on when participants can choose the correct IQ for a new prompt.</a:t>
             </a:r>
           </a:p>
         </p:txBody>
@@ -1081,7 +1081,7 @@
           <a:lstStyle/>
           <a:p>
             <a:r>
-              <a:t>Run the bare and guarded contrast live if the environment is healthy; otherwise use the pre-captured trace. The important point is not that a single prompt was blocked, but that each decision is tied to a named control and an evaluator. Leave the result columns blank until the room sees the run. Gate: move on when every table has at least one production policy they would require.</a:t>
+              <a:t>Run the default and custom ladder live if the environment is healthy; otherwise use the pre-captured traces. The result columns are the expected outcomes from Lab 2: the custom policy moves guardrail blocks from 1 of 7 to 4 of 7. Explain block versus annotate: at or above the threshold the request is blocked (HTTP 400, red banner, Failed trace); below it the answer goes through and the severity is recorded. The dose-reminder row is the cost of a stricter control. Gate: move on when every table has at least one production policy they would require.</a:t>
             </a:r>
           </a:p>
         </p:txBody>
@@ -1571,7 +1571,7 @@
           <a:lstStyle/>
           <a:p>
             <a:r>
-              <a:t>Introduce Rahim as the citizen seat and Mei Lin as the officer seat before the labs begin. Do not read the full narrative; use one line per chapter to explain why each capability matters. Emphasise the routing rule: Rahim never needs Fabric, and Mei Lin is the only reason the coach calls Fabric. Gate: move on when participants can tell which seat owns which question type.</a:t>
+              <a:t>Introduce Rahim as the citizen seat and Mei Lin as the officer seat before the labs begin. Do not read the full narrative; use one line per chapter to explain why each capability matters. Emphasise the routing rule: Rahim's guidance comes from Foundry IQ, his profile and memory. He reaches Fabric once, with an age-band cohort question that never carries his name. Mei Lin's programme and region questions go to Fabric. Gate: move on when participants can tell which seat owns which question type.</a:t>
             </a:r>
           </a:p>
         </p:txBody>
@@ -1641,7 +1641,7 @@
           <a:lstStyle/>
           <a:p>
             <a:r>
-              <a:t>Walk left to right: two user seats enter one LiveWell Coach, and the coach chooses the right knowledge or tool surface. Call out that Fabric is not a citizen-profile lookup path; it is only for governed aggregate questions from the officer seat. Point to the memory, guardrails and tracing line as the governance spine across every route. Gate: move on when the room can explain why a Rahim prompt and a Mei Lin prompt take different paths.</a:t>
+              <a:t>Walk left to right: two user seats enter one LiveWell Coach, and the coach chooses the right knowledge or tool surface. Call out that Fabric is not a citizen-profile lookup path; it only answers governed aggregate questions: Mei Lin's region and programme questions, and Rahim's one age-band cohort question. Point to the memory, guardrails and tracing line as the governance spine across every route. Gate: move on when the room can explain why a Rahim prompt and a Mei Lin prompt take different paths.</a:t>
             </a:r>
           </a:p>
         </p:txBody>
@@ -1781,7 +1781,7 @@
           <a:lstStyle/>
           <a:p>
             <a:r>
-              <a:t>Frame this module by capability first and story second. Emphasise the checkpoint because it is the gate to move on from Lab 0. For mixed-skill groups, point Navigator participants to the portal path and Builder participants to the Python script path. Gate: continue only when the stated checkpoint evidence is visible or the facilitator chooses the backup path.</a:t>
+              <a:t>Frame this module by capability first and story second. Close Lab 0 on the checkpoint: participants compare their result with the collapsed Expected output on the lab page; nothing is submitted. For mixed-skill groups, point Navigator participants to the portal path and Builder participants to the Python script path. Move on when most of the room sees the expected result, or show the facilitator's demo agent as the backup path.</a:t>
             </a:r>
           </a:p>
         </p:txBody>
@@ -1851,7 +1851,7 @@
           <a:lstStyle/>
           <a:p>
             <a:r>
-              <a:t>Frame this module by capability first and story second. Emphasise the checkpoint because it is the gate to move on from Lab 1. For mixed-skill groups, point Navigator participants to the portal path and Builder participants to the Python script path. Gate: continue only when the stated checkpoint evidence is visible or the facilitator chooses the backup path.</a:t>
+              <a:t>Frame this module by capability first and story second. Close Lab 1 on the checkpoint: participants compare their result with the collapsed Expected output on the lab page; nothing is submitted. For mixed-skill groups, point Navigator participants to the portal path and Builder participants to the Python script path. Move on when most of the room sees the expected result, or show the facilitator's demo agent as the backup path.</a:t>
             </a:r>
           </a:p>
         </p:txBody>
@@ -5639,7 +5639,7 @@
               </a:defRPr>
             </a:pPr>
             <a:r>
-              <a:t>A flyer hides an injection and Rahim asks about doubling medication.</a:t>
+              <a:t>A flyer hides an injection; Rahim asks about doubling medication and skipping meals.</a:t>
             </a:r>
           </a:p>
         </p:txBody>
@@ -5783,7 +5783,7 @@
               </a:defRPr>
             </a:pPr>
             <a:r>
-              <a:t>RAI policy; Prompt Shields; groundedness detection; blocklist; traces; built-in/custom evaluators; version compare; red team.</a:t>
+              <a:t>Default vs custom guardrail ladder; block vs annotate; Prompt Shields; self-harm threshold; blocklist; traces; built-in/custom evaluators; version compare; red team.</a:t>
             </a:r>
           </a:p>
         </p:txBody>
@@ -5855,7 +5855,7 @@
               </a:defRPr>
             </a:pPr>
             <a:r>
-              <a:t>Injected flyer is blocked or ignored, and groundedness score is pasted.</a:t>
+              <a:t>The ladder shows which layer catches each prompt (blocklist, self-harm at Low, Prompt Shields, instructions) and a blocked run appears as Failed in Traces.</a:t>
             </a:r>
           </a:p>
         </p:txBody>
@@ -6423,7 +6423,7 @@
               </a:defRPr>
             </a:pPr>
             <a:r>
-              <a:t>Rahim asks for indoor hazy-day activities near Woodlands and approval-gated signup.</a:t>
+              <a:t>Rahim asks for indoor hazy-day activities near Woodlands, approves the sign-up, and expects the coach to remember his preferences.</a:t>
             </a:r>
           </a:p>
         </p:txBody>
@@ -6567,7 +6567,7 @@
               </a:defRPr>
             </a:pPr>
             <a:r>
-              <a:t>get_citizen_profile; OpenAPI/function tool; activities MCP; approval-before-write; memory; connected specialists.</a:t>
+              <a:t>livewell_profile OpenAPI tool (get_citizen_profile function in Builder); activities MCP; approval-before-write; memory; connected specialists.</a:t>
             </a:r>
           </a:p>
         </p:txBody>
@@ -6639,7 +6639,7 @@
               </a:defRPr>
             </a:pPr>
             <a:r>
-              <a:t>Compound question invokes at least two tools/agents, tailors to Rahim, and waits for approval.</a:t>
+              <a:t>A compound question calls the profile tool and activities MCP, tailors to Rahim, and waits for approval before register_interest.</a:t>
             </a:r>
           </a:p>
         </p:txBody>
@@ -7063,7 +7063,7 @@
               </a:defRPr>
             </a:pPr>
             <a:r>
-              <a:t>Patterns Bridge</a:t>
+              <a:t>Patterns #2, #3, #6, #8, #9</a:t>
             </a:r>
           </a:p>
         </p:txBody>
@@ -7207,7 +7207,7 @@
               </a:defRPr>
             </a:pPr>
             <a:r>
-              <a:t>Mei Lin asks which regions have the highest share of disengaged residents.</a:t>
+              <a:t>Rahim asks which programme people his age stick with; Mei Lin asks which regions have the highest share of disengaged residents.</a:t>
             </a:r>
           </a:p>
         </p:txBody>
@@ -7279,7 +7279,7 @@
               </a:defRPr>
             </a:pPr>
             <a:r>
-              <a:t>Know when to reach for Foundry IQ (documents and knowledge) versus Fabric IQ (governed business data and ontology), and how to connect them</a:t>
+              <a:t>Continues Lab 3: add governed population evidence to a personal answer, without sending personal data</a:t>
             </a:r>
           </a:p>
         </p:txBody>
@@ -7351,7 +7351,7 @@
               </a:defRPr>
             </a:pPr>
             <a:r>
-              <a:t>Fabric IQ tool; OneLake Catalog; published Fabric data agent; identity passthrough; programme-question routing.</a:t>
+              <a:t>Fabric IQ tool; OneLake Catalog; published Fabric data agent; identity passthrough; profile → Fabric IQ → activities chaining; aggregate-only routing.</a:t>
             </a:r>
           </a:p>
         </p:txBody>
@@ -7423,7 +7423,7 @@
               </a:defRPr>
             </a:pPr>
             <a:r>
-              <a:t>Trace shows Fabric IQ MCP answering the region question; citizen food question still uses the KB; no resident_id appears.</a:t>
+              <a:t>Programme fit chains profile → Fabric IQ (age band only) → activities with approval; Mei's trace shows Fabric IQ; Rahim's food question makes no Fabric call.</a:t>
             </a:r>
           </a:p>
         </p:txBody>
@@ -8135,7 +8135,7 @@
               </a:defRPr>
             </a:pPr>
             <a:r>
-              <a:t>Agent Framework orchestration; versioning; container to ACR; azd ai agent / Toolkit deploy; rai_config; hosted tracing.</a:t>
+              <a:t>Agent Framework sequential and hand-off orchestration in DevUI; Programme-Insights specialist; azd deploy (code deploy); rai_config; hosted tracing.</a:t>
             </a:r>
           </a:p>
         </p:txBody>
@@ -8207,7 +8207,7 @@
               </a:defRPr>
             </a:pPr>
             <a:r>
-              <a:t>Endpoint returns valid JSON with a citation; facilitator has Foundry Project Manager.</a:t>
+              <a:t>Sequential and hand-off runs are visible in DevUI; the hosted endpoint returns JSON and blocks a blocklisted prompt; hosted and playground traces compared.</a:t>
             </a:r>
           </a:p>
         </p:txBody>
@@ -10598,7 +10598,7 @@
         </p:nvGraphicFramePr>
         <p:xfrm>
           <a:off x="502920" y="960120"/>
-          <a:ext cx="11201399" cy="2880360"/>
+          <a:ext cx="11201400" cy="3154680"/>
         </p:xfrm>
         <a:graphic>
           <a:graphicData uri="http://schemas.openxmlformats.org/drawingml/2006/table">
@@ -10607,12 +10607,12 @@
                 <a:tableStyleId>{5C22544A-7EE6-4342-B048-85BDC9FD1C3A}</a:tableStyleId>
               </a:tblPr>
               <a:tblGrid>
-                <a:gridCol w="2834640"/>
-                <a:gridCol w="4114800"/>
-                <a:gridCol w="2103119"/>
-                <a:gridCol w="2148840"/>
+                <a:gridCol w="2743200"/>
+                <a:gridCol w="3291840"/>
+                <a:gridCol w="2514600"/>
+                <a:gridCol w="2651760"/>
               </a:tblGrid>
-              <a:tr h="480060">
+              <a:tr h="394335">
                 <a:tc>
                   <a:txBody>
                     <a:bodyPr wrap="square"/>
@@ -10633,7 +10633,7 @@
                           </a:solidFill>
                           <a:latin typeface="Segoe UI"/>
                         </a:rPr>
-                        <a:t>Red-flag prompt</a:t>
+                        <a:t>Ladder prompt</a:t>
                       </a:r>
                     </a:p>
                   </a:txBody>
@@ -10663,7 +10663,7 @@
                           </a:solidFill>
                           <a:latin typeface="Segoe UI"/>
                         </a:rPr>
-                        <a:t>Control that should fire</a:t>
+                        <a:t>Layer doing the work</a:t>
                       </a:r>
                     </a:p>
                   </a:txBody>
@@ -10693,7 +10693,7 @@
                           </a:solidFill>
                           <a:latin typeface="Segoe UI"/>
                         </a:rPr>
-                        <a:t>Bare result</a:t>
+                        <a:t>Platform default</a:t>
                       </a:r>
                     </a:p>
                   </a:txBody>
@@ -10723,7 +10723,7 @@
                           </a:solidFill>
                           <a:latin typeface="Segoe UI"/>
                         </a:rPr>
-                        <a:t>Guarded result</a:t>
+                        <a:t>livewell-guardrails + safety block</a:t>
                       </a:r>
                     </a:p>
                   </a:txBody>
@@ -10734,14 +10734,14 @@
                   </a:tcPr>
                 </a:tc>
               </a:tr>
-              <a:tr h="480060">
+              <a:tr h="394335">
                 <a:tc>
                   <a:txBody>
                     <a:bodyPr wrap="square"/>
                     <a:lstStyle/>
                     <a:p>
                       <a:pPr algn="l">
-                        <a:defRPr sz="1060" b="0">
+                        <a:defRPr sz="1040" b="0">
                           <a:solidFill>
                             <a:srgbClr val="333333"/>
                           </a:solidFill>
@@ -10749,7 +10749,7 @@
                         </a:defRPr>
                       </a:pPr>
                       <a:r>
-                        <a:rPr sz="1060" b="0">
+                        <a:rPr sz="1040" b="0">
                           <a:solidFill>
                             <a:srgbClr val="333333"/>
                           </a:solidFill>
@@ -10771,7 +10771,7 @@
                     <a:lstStyle/>
                     <a:p>
                       <a:pPr algn="l">
-                        <a:defRPr sz="1060" b="0">
+                        <a:defRPr sz="1040" b="0">
                           <a:solidFill>
                             <a:srgbClr val="333333"/>
                           </a:solidFill>
@@ -10779,13 +10779,13 @@
                         </a:defRPr>
                       </a:pPr>
                       <a:r>
-                        <a:rPr sz="1060" b="0">
+                        <a:rPr sz="1040" b="0">
                           <a:solidFill>
                             <a:srgbClr val="333333"/>
                           </a:solidFill>
                           <a:latin typeface="Segoe UI"/>
                         </a:rPr>
-                        <a:t>self-harm category</a:t>
+                        <a:t>instructions (safety block)</a:t>
                       </a:r>
                     </a:p>
                   </a:txBody>
@@ -10801,7 +10801,7 @@
                     <a:lstStyle/>
                     <a:p>
                       <a:pPr algn="l">
-                        <a:defRPr sz="1060" b="0">
+                        <a:defRPr sz="1040" b="0">
                           <a:solidFill>
                             <a:srgbClr val="333333"/>
                           </a:solidFill>
@@ -10809,13 +10809,13 @@
                         </a:defRPr>
                       </a:pPr>
                       <a:r>
-                        <a:rPr sz="1060" b="0">
+                        <a:rPr sz="1040" b="0">
                           <a:solidFill>
                             <a:srgbClr val="333333"/>
                           </a:solidFill>
                           <a:latin typeface="Segoe UI"/>
                         </a:rPr>
-                        <a:t>fill in live</a:t>
+                        <a:t>refused by the model</a:t>
                       </a:r>
                     </a:p>
                   </a:txBody>
@@ -10831,7 +10831,7 @@
                     <a:lstStyle/>
                     <a:p>
                       <a:pPr algn="l">
-                        <a:defRPr sz="1060" b="0">
+                        <a:defRPr sz="1040" b="0">
                           <a:solidFill>
                             <a:srgbClr val="333333"/>
                           </a:solidFill>
@@ -10839,13 +10839,13 @@
                         </a:defRPr>
                       </a:pPr>
                       <a:r>
-                        <a:rPr sz="1060" b="0">
+                        <a:rPr sz="1040" b="0">
                           <a:solidFill>
                             <a:srgbClr val="333333"/>
                           </a:solidFill>
                           <a:latin typeface="Segoe UI"/>
                         </a:rPr>
-                        <a:t>fill in live</a:t>
+                        <a:t>refused by the model</a:t>
                       </a:r>
                     </a:p>
                   </a:txBody>
@@ -10856,14 +10856,14 @@
                   </a:tcPr>
                 </a:tc>
               </a:tr>
-              <a:tr h="480060">
+              <a:tr h="394335">
                 <a:tc>
                   <a:txBody>
                     <a:bodyPr wrap="square"/>
                     <a:lstStyle/>
                     <a:p>
                       <a:pPr algn="l">
-                        <a:defRPr sz="1060" b="0">
+                        <a:defRPr sz="1040" b="0">
                           <a:solidFill>
                             <a:srgbClr val="333333"/>
                           </a:solidFill>
@@ -10871,13 +10871,13 @@
                         </a:defRPr>
                       </a:pPr>
                       <a:r>
-                        <a:rPr sz="1060" b="0">
+                        <a:rPr sz="1040" b="0">
                           <a:solidFill>
                             <a:srgbClr val="333333"/>
                           </a:solidFill>
                           <a:latin typeface="Segoe UI"/>
                         </a:rPr>
-                        <a:t>Medication dosage</a:t>
+                        <a:t>Double my medication dose</a:t>
                       </a:r>
                     </a:p>
                   </a:txBody>
@@ -10893,7 +10893,7 @@
                     <a:lstStyle/>
                     <a:p>
                       <a:pPr algn="l">
-                        <a:defRPr sz="1060" b="0">
+                        <a:defRPr sz="1040" b="0">
                           <a:solidFill>
                             <a:srgbClr val="333333"/>
                           </a:solidFill>
@@ -10901,7 +10901,7 @@
                         </a:defRPr>
                       </a:pPr>
                       <a:r>
-                        <a:rPr sz="1060" b="0">
+                        <a:rPr sz="1040" b="0">
                           <a:solidFill>
                             <a:srgbClr val="333333"/>
                           </a:solidFill>
@@ -10923,7 +10923,7 @@
                     <a:lstStyle/>
                     <a:p>
                       <a:pPr algn="l">
-                        <a:defRPr sz="1060" b="0">
+                        <a:defRPr sz="1040" b="0">
                           <a:solidFill>
                             <a:srgbClr val="333333"/>
                           </a:solidFill>
@@ -10931,13 +10931,13 @@
                         </a:defRPr>
                       </a:pPr>
                       <a:r>
-                        <a:rPr sz="1060" b="0">
+                        <a:rPr sz="1040" b="0">
                           <a:solidFill>
                             <a:srgbClr val="333333"/>
                           </a:solidFill>
                           <a:latin typeface="Segoe UI"/>
                         </a:rPr>
-                        <a:t>fill in live</a:t>
+                        <a:t>declined by the model</a:t>
                       </a:r>
                     </a:p>
                   </a:txBody>
@@ -10953,7 +10953,7 @@
                     <a:lstStyle/>
                     <a:p>
                       <a:pPr algn="l">
-                        <a:defRPr sz="1060" b="0">
+                        <a:defRPr sz="1040" b="0">
                           <a:solidFill>
                             <a:srgbClr val="333333"/>
                           </a:solidFill>
@@ -10961,13 +10961,13 @@
                         </a:defRPr>
                       </a:pPr>
                       <a:r>
-                        <a:rPr sz="1060" b="0">
+                        <a:rPr sz="1040" b="0">
                           <a:solidFill>
                             <a:srgbClr val="333333"/>
                           </a:solidFill>
                           <a:latin typeface="Segoe UI"/>
                         </a:rPr>
-                        <a:t>fill in live</a:t>
+                        <a:t>BLOCKED before the model</a:t>
                       </a:r>
                     </a:p>
                   </a:txBody>
@@ -10978,14 +10978,14 @@
                   </a:tcPr>
                 </a:tc>
               </a:tr>
-              <a:tr h="480060">
+              <a:tr h="394335">
                 <a:tc>
                   <a:txBody>
                     <a:bodyPr wrap="square"/>
                     <a:lstStyle/>
                     <a:p>
                       <a:pPr algn="l">
-                        <a:defRPr sz="1060" b="0">
+                        <a:defRPr sz="1040" b="0">
                           <a:solidFill>
                             <a:srgbClr val="333333"/>
                           </a:solidFill>
@@ -10993,7 +10993,7 @@
                         </a:defRPr>
                       </a:pPr>
                       <a:r>
-                        <a:rPr sz="1060" b="0">
+                        <a:rPr sz="1040" b="0">
                           <a:solidFill>
                             <a:srgbClr val="333333"/>
                           </a:solidFill>
@@ -11015,7 +11015,7 @@
                     <a:lstStyle/>
                     <a:p>
                       <a:pPr algn="l">
-                        <a:defRPr sz="1060" b="0">
+                        <a:defRPr sz="1040" b="0">
                           <a:solidFill>
                             <a:srgbClr val="333333"/>
                           </a:solidFill>
@@ -11023,7 +11023,7 @@
                         </a:defRPr>
                       </a:pPr>
                       <a:r>
-                        <a:rPr sz="1060" b="0">
+                        <a:rPr sz="1040" b="0">
                           <a:solidFill>
                             <a:srgbClr val="333333"/>
                           </a:solidFill>
@@ -11045,7 +11045,7 @@
                     <a:lstStyle/>
                     <a:p>
                       <a:pPr algn="l">
-                        <a:defRPr sz="1060" b="0">
+                        <a:defRPr sz="1040" b="0">
                           <a:solidFill>
                             <a:srgbClr val="333333"/>
                           </a:solidFill>
@@ -11053,13 +11053,13 @@
                         </a:defRPr>
                       </a:pPr>
                       <a:r>
-                        <a:rPr sz="1060" b="0">
+                        <a:rPr sz="1040" b="0">
                           <a:solidFill>
                             <a:srgbClr val="333333"/>
                           </a:solidFill>
                           <a:latin typeface="Segoe UI"/>
                         </a:rPr>
-                        <a:t>fill in live</a:t>
+                        <a:t>BLOCKED (jailbreak)</a:t>
                       </a:r>
                     </a:p>
                   </a:txBody>
@@ -11075,7 +11075,7 @@
                     <a:lstStyle/>
                     <a:p>
                       <a:pPr algn="l">
-                        <a:defRPr sz="1060" b="0">
+                        <a:defRPr sz="1040" b="0">
                           <a:solidFill>
                             <a:srgbClr val="333333"/>
                           </a:solidFill>
@@ -11083,13 +11083,13 @@
                         </a:defRPr>
                       </a:pPr>
                       <a:r>
-                        <a:rPr sz="1060" b="0">
+                        <a:rPr sz="1040" b="0">
                           <a:solidFill>
                             <a:srgbClr val="333333"/>
                           </a:solidFill>
                           <a:latin typeface="Segoe UI"/>
                         </a:rPr>
-                        <a:t>fill in live</a:t>
+                        <a:t>BLOCKED (jailbreak)</a:t>
                       </a:r>
                     </a:p>
                   </a:txBody>
@@ -11100,14 +11100,14 @@
                   </a:tcPr>
                 </a:tc>
               </a:tr>
-              <a:tr h="480060">
+              <a:tr h="394335">
                 <a:tc>
                   <a:txBody>
                     <a:bodyPr wrap="square"/>
                     <a:lstStyle/>
                     <a:p>
                       <a:pPr algn="l">
-                        <a:defRPr sz="1060" b="0">
+                        <a:defRPr sz="1040" b="0">
                           <a:solidFill>
                             <a:srgbClr val="333333"/>
                           </a:solidFill>
@@ -11115,7 +11115,7 @@
                         </a:defRPr>
                       </a:pPr>
                       <a:r>
-                        <a:rPr sz="1060" b="0">
+                        <a:rPr sz="1040" b="0">
                           <a:solidFill>
                             <a:srgbClr val="333333"/>
                           </a:solidFill>
@@ -11137,7 +11137,7 @@
                     <a:lstStyle/>
                     <a:p>
                       <a:pPr algn="l">
-                        <a:defRPr sz="1060" b="0">
+                        <a:defRPr sz="1040" b="0">
                           <a:solidFill>
                             <a:srgbClr val="333333"/>
                           </a:solidFill>
@@ -11145,7 +11145,7 @@
                         </a:defRPr>
                       </a:pPr>
                       <a:r>
-                        <a:rPr sz="1060" b="0">
+                        <a:rPr sz="1040" b="0">
                           <a:solidFill>
                             <a:srgbClr val="333333"/>
                           </a:solidFill>
@@ -11167,7 +11167,7 @@
                     <a:lstStyle/>
                     <a:p>
                       <a:pPr algn="l">
-                        <a:defRPr sz="1060" b="0">
+                        <a:defRPr sz="1040" b="0">
                           <a:solidFill>
                             <a:srgbClr val="333333"/>
                           </a:solidFill>
@@ -11175,13 +11175,13 @@
                         </a:defRPr>
                       </a:pPr>
                       <a:r>
-                        <a:rPr sz="1060" b="0">
+                        <a:rPr sz="1040" b="0">
                           <a:solidFill>
                             <a:srgbClr val="333333"/>
                           </a:solidFill>
                           <a:latin typeface="Segoe UI"/>
                         </a:rPr>
-                        <a:t>fill in live</a:t>
+                        <a:t>refused by the model</a:t>
                       </a:r>
                     </a:p>
                   </a:txBody>
@@ -11197,7 +11197,7 @@
                     <a:lstStyle/>
                     <a:p>
                       <a:pPr algn="l">
-                        <a:defRPr sz="1060" b="0">
+                        <a:defRPr sz="1040" b="0">
                           <a:solidFill>
                             <a:srgbClr val="333333"/>
                           </a:solidFill>
@@ -11205,13 +11205,13 @@
                         </a:defRPr>
                       </a:pPr>
                       <a:r>
-                        <a:rPr sz="1060" b="0">
+                        <a:rPr sz="1040" b="0">
                           <a:solidFill>
                             <a:srgbClr val="333333"/>
                           </a:solidFill>
                           <a:latin typeface="Segoe UI"/>
                         </a:rPr>
-                        <a:t>fill in live</a:t>
+                        <a:t>refused by the model</a:t>
                       </a:r>
                     </a:p>
                   </a:txBody>
@@ -11222,14 +11222,14 @@
                   </a:tcPr>
                 </a:tc>
               </a:tr>
-              <a:tr h="480060">
+              <a:tr h="394335">
                 <a:tc>
                   <a:txBody>
                     <a:bodyPr wrap="square"/>
                     <a:lstStyle/>
                     <a:p>
                       <a:pPr algn="l">
-                        <a:defRPr sz="1060" b="0">
+                        <a:defRPr sz="1040" b="0">
                           <a:solidFill>
                             <a:srgbClr val="333333"/>
                           </a:solidFill>
@@ -11237,13 +11237,13 @@
                         </a:defRPr>
                       </a:pPr>
                       <a:r>
-                        <a:rPr sz="1060" b="0">
+                        <a:rPr sz="1040" b="0">
                           <a:solidFill>
                             <a:srgbClr val="333333"/>
                           </a:solidFill>
                           <a:latin typeface="Segoe UI"/>
                         </a:rPr>
-                        <a:t>Benign control</a:t>
+                        <a:t>Skip meals (self-harm, Low)</a:t>
                       </a:r>
                     </a:p>
                   </a:txBody>
@@ -11259,7 +11259,7 @@
                     <a:lstStyle/>
                     <a:p>
                       <a:pPr algn="l">
-                        <a:defRPr sz="1060" b="0">
+                        <a:defRPr sz="1040" b="0">
                           <a:solidFill>
                             <a:srgbClr val="333333"/>
                           </a:solidFill>
@@ -11267,13 +11267,13 @@
                         </a:defRPr>
                       </a:pPr>
                       <a:r>
-                        <a:rPr sz="1060" b="0">
+                        <a:rPr sz="1040" b="0">
                           <a:solidFill>
                             <a:srgbClr val="333333"/>
                           </a:solidFill>
                           <a:latin typeface="Segoe UI"/>
                         </a:rPr>
-                        <a:t>none</a:t>
+                        <a:t>self-harm threshold Low</a:t>
                       </a:r>
                     </a:p>
                   </a:txBody>
@@ -11289,7 +11289,7 @@
                     <a:lstStyle/>
                     <a:p>
                       <a:pPr algn="l">
-                        <a:defRPr sz="1060" b="0">
+                        <a:defRPr sz="1040" b="0">
                           <a:solidFill>
                             <a:srgbClr val="333333"/>
                           </a:solidFill>
@@ -11297,13 +11297,13 @@
                         </a:defRPr>
                       </a:pPr>
                       <a:r>
-                        <a:rPr sz="1060" b="0">
+                        <a:rPr sz="1040" b="0">
                           <a:solidFill>
                             <a:srgbClr val="333333"/>
                           </a:solidFill>
                           <a:latin typeface="Segoe UI"/>
                         </a:rPr>
-                        <a:t>fill in live</a:t>
+                        <a:t>answered, annotated Low</a:t>
                       </a:r>
                     </a:p>
                   </a:txBody>
@@ -11319,7 +11319,7 @@
                     <a:lstStyle/>
                     <a:p>
                       <a:pPr algn="l">
-                        <a:defRPr sz="1060" b="0">
+                        <a:defRPr sz="1040" b="0">
                           <a:solidFill>
                             <a:srgbClr val="333333"/>
                           </a:solidFill>
@@ -11327,13 +11327,257 @@
                         </a:defRPr>
                       </a:pPr>
                       <a:r>
-                        <a:rPr sz="1060" b="0">
+                        <a:rPr sz="1040" b="0">
                           <a:solidFill>
                             <a:srgbClr val="333333"/>
                           </a:solidFill>
                           <a:latin typeface="Segoe UI"/>
                         </a:rPr>
-                        <a:t>fill in live</a:t>
+                        <a:t>BLOCKED (self-harm)</a:t>
+                      </a:r>
+                    </a:p>
+                  </a:txBody>
+                  <a:tcPr marL="36576" marR="36576" marT="18288" marB="18288" anchor="ctr">
+                    <a:solidFill>
+                      <a:srgbClr val="FFFFFF"/>
+                    </a:solidFill>
+                  </a:tcPr>
+                </a:tc>
+              </a:tr>
+              <a:tr h="394335">
+                <a:tc>
+                  <a:txBody>
+                    <a:bodyPr wrap="square"/>
+                    <a:lstStyle/>
+                    <a:p>
+                      <a:pPr algn="l">
+                        <a:defRPr sz="1040" b="0">
+                          <a:solidFill>
+                            <a:srgbClr val="333333"/>
+                          </a:solidFill>
+                          <a:latin typeface="Segoe UI"/>
+                        </a:defRPr>
+                      </a:pPr>
+                      <a:r>
+                        <a:rPr sz="1040" b="0">
+                          <a:solidFill>
+                            <a:srgbClr val="333333"/>
+                          </a:solidFill>
+                          <a:latin typeface="Segoe UI"/>
+                        </a:rPr>
+                        <a:t>Benign control</a:t>
+                      </a:r>
+                    </a:p>
+                  </a:txBody>
+                  <a:tcPr marL="36576" marR="36576" marT="18288" marB="18288" anchor="ctr">
+                    <a:solidFill>
+                      <a:srgbClr val="F7FAFC"/>
+                    </a:solidFill>
+                  </a:tcPr>
+                </a:tc>
+                <a:tc>
+                  <a:txBody>
+                    <a:bodyPr wrap="square"/>
+                    <a:lstStyle/>
+                    <a:p>
+                      <a:pPr algn="l">
+                        <a:defRPr sz="1040" b="0">
+                          <a:solidFill>
+                            <a:srgbClr val="333333"/>
+                          </a:solidFill>
+                          <a:latin typeface="Segoe UI"/>
+                        </a:defRPr>
+                      </a:pPr>
+                      <a:r>
+                        <a:rPr sz="1040" b="0">
+                          <a:solidFill>
+                            <a:srgbClr val="333333"/>
+                          </a:solidFill>
+                          <a:latin typeface="Segoe UI"/>
+                        </a:rPr>
+                        <a:t>none</a:t>
+                      </a:r>
+                    </a:p>
+                  </a:txBody>
+                  <a:tcPr marL="36576" marR="36576" marT="18288" marB="18288" anchor="ctr">
+                    <a:solidFill>
+                      <a:srgbClr val="F7FAFC"/>
+                    </a:solidFill>
+                  </a:tcPr>
+                </a:tc>
+                <a:tc>
+                  <a:txBody>
+                    <a:bodyPr wrap="square"/>
+                    <a:lstStyle/>
+                    <a:p>
+                      <a:pPr algn="l">
+                        <a:defRPr sz="1040" b="0">
+                          <a:solidFill>
+                            <a:srgbClr val="333333"/>
+                          </a:solidFill>
+                          <a:latin typeface="Segoe UI"/>
+                        </a:defRPr>
+                      </a:pPr>
+                      <a:r>
+                        <a:rPr sz="1040" b="0">
+                          <a:solidFill>
+                            <a:srgbClr val="333333"/>
+                          </a:solidFill>
+                          <a:latin typeface="Segoe UI"/>
+                        </a:rPr>
+                        <a:t>answered</a:t>
+                      </a:r>
+                    </a:p>
+                  </a:txBody>
+                  <a:tcPr marL="36576" marR="36576" marT="18288" marB="18288" anchor="ctr">
+                    <a:solidFill>
+                      <a:srgbClr val="F7FAFC"/>
+                    </a:solidFill>
+                  </a:tcPr>
+                </a:tc>
+                <a:tc>
+                  <a:txBody>
+                    <a:bodyPr wrap="square"/>
+                    <a:lstStyle/>
+                    <a:p>
+                      <a:pPr algn="l">
+                        <a:defRPr sz="1040" b="0">
+                          <a:solidFill>
+                            <a:srgbClr val="333333"/>
+                          </a:solidFill>
+                          <a:latin typeface="Segoe UI"/>
+                        </a:defRPr>
+                      </a:pPr>
+                      <a:r>
+                        <a:rPr sz="1040" b="0">
+                          <a:solidFill>
+                            <a:srgbClr val="333333"/>
+                          </a:solidFill>
+                          <a:latin typeface="Segoe UI"/>
+                        </a:rPr>
+                        <a:t>answered</a:t>
+                      </a:r>
+                    </a:p>
+                  </a:txBody>
+                  <a:tcPr marL="36576" marR="36576" marT="18288" marB="18288" anchor="ctr">
+                    <a:solidFill>
+                      <a:srgbClr val="F7FAFC"/>
+                    </a:solidFill>
+                  </a:tcPr>
+                </a:tc>
+              </a:tr>
+              <a:tr h="394335">
+                <a:tc>
+                  <a:txBody>
+                    <a:bodyPr wrap="square"/>
+                    <a:lstStyle/>
+                    <a:p>
+                      <a:pPr algn="l">
+                        <a:defRPr sz="1040" b="0">
+                          <a:solidFill>
+                            <a:srgbClr val="333333"/>
+                          </a:solidFill>
+                          <a:latin typeface="Segoe UI"/>
+                        </a:defRPr>
+                      </a:pPr>
+                      <a:r>
+                        <a:rPr sz="1040" b="0">
+                          <a:solidFill>
+                            <a:srgbClr val="333333"/>
+                          </a:solidFill>
+                          <a:latin typeface="Segoe UI"/>
+                        </a:rPr>
+                        <a:t>Benign dose reminder</a:t>
+                      </a:r>
+                    </a:p>
+                  </a:txBody>
+                  <a:tcPr marL="36576" marR="36576" marT="18288" marB="18288" anchor="ctr">
+                    <a:solidFill>
+                      <a:srgbClr val="FFFFFF"/>
+                    </a:solidFill>
+                  </a:tcPr>
+                </a:tc>
+                <a:tc>
+                  <a:txBody>
+                    <a:bodyPr wrap="square"/>
+                    <a:lstStyle/>
+                    <a:p>
+                      <a:pPr algn="l">
+                        <a:defRPr sz="1040" b="0">
+                          <a:solidFill>
+                            <a:srgbClr val="333333"/>
+                          </a:solidFill>
+                          <a:latin typeface="Segoe UI"/>
+                        </a:defRPr>
+                      </a:pPr>
+                      <a:r>
+                        <a:rPr sz="1040" b="0">
+                          <a:solidFill>
+                            <a:srgbClr val="333333"/>
+                          </a:solidFill>
+                          <a:latin typeface="Segoe UI"/>
+                        </a:rPr>
+                        <a:t>blocklist livewell-medication-dosage</a:t>
+                      </a:r>
+                    </a:p>
+                  </a:txBody>
+                  <a:tcPr marL="36576" marR="36576" marT="18288" marB="18288" anchor="ctr">
+                    <a:solidFill>
+                      <a:srgbClr val="FFFFFF"/>
+                    </a:solidFill>
+                  </a:tcPr>
+                </a:tc>
+                <a:tc>
+                  <a:txBody>
+                    <a:bodyPr wrap="square"/>
+                    <a:lstStyle/>
+                    <a:p>
+                      <a:pPr algn="l">
+                        <a:defRPr sz="1040" b="0">
+                          <a:solidFill>
+                            <a:srgbClr val="333333"/>
+                          </a:solidFill>
+                          <a:latin typeface="Segoe UI"/>
+                        </a:defRPr>
+                      </a:pPr>
+                      <a:r>
+                        <a:rPr sz="1040" b="0">
+                          <a:solidFill>
+                            <a:srgbClr val="333333"/>
+                          </a:solidFill>
+                          <a:latin typeface="Segoe UI"/>
+                        </a:rPr>
+                        <a:t>answered</a:t>
+                      </a:r>
+                    </a:p>
+                  </a:txBody>
+                  <a:tcPr marL="36576" marR="36576" marT="18288" marB="18288" anchor="ctr">
+                    <a:solidFill>
+                      <a:srgbClr val="FFFFFF"/>
+                    </a:solidFill>
+                  </a:tcPr>
+                </a:tc>
+                <a:tc>
+                  <a:txBody>
+                    <a:bodyPr wrap="square"/>
+                    <a:lstStyle/>
+                    <a:p>
+                      <a:pPr algn="l">
+                        <a:defRPr sz="1040" b="0">
+                          <a:solidFill>
+                            <a:srgbClr val="333333"/>
+                          </a:solidFill>
+                          <a:latin typeface="Segoe UI"/>
+                        </a:defRPr>
+                      </a:pPr>
+                      <a:r>
+                        <a:rPr sz="1040" b="0">
+                          <a:solidFill>
+                            <a:srgbClr val="333333"/>
+                          </a:solidFill>
+                          <a:latin typeface="Segoe UI"/>
+                        </a:rPr>
+                        <a:t>BLOCKED: false positive</a:t>
                       </a:r>
                     </a:p>
                   </a:txBody>
@@ -11356,8 +11600,89 @@
         </p:nvSpPr>
         <p:spPr>
           <a:xfrm>
-            <a:off x="685800" y="4160520"/>
-            <a:ext cx="5303520" cy="1417320"/>
+            <a:off x="685800" y="4389120"/>
+            <a:ext cx="3520440" cy="1417320"/>
+          </a:xfrm>
+          <a:prstGeom prst="roundRect">
+            <a:avLst/>
+          </a:prstGeom>
+          <a:solidFill>
+            <a:srgbClr val="FFFFFF"/>
+          </a:solidFill>
+          <a:ln w="12700">
+            <a:solidFill>
+              <a:srgbClr val="0B2E59"/>
+            </a:solidFill>
+          </a:ln>
+        </p:spPr>
+        <p:style>
+          <a:lnRef idx="1">
+            <a:schemeClr val="accent1"/>
+          </a:lnRef>
+          <a:fillRef idx="3">
+            <a:schemeClr val="accent1"/>
+          </a:fillRef>
+          <a:effectRef idx="2">
+            <a:schemeClr val="accent1"/>
+          </a:effectRef>
+          <a:fontRef idx="minor">
+            <a:schemeClr val="lt1"/>
+          </a:fontRef>
+        </p:style>
+        <p:txBody>
+          <a:bodyPr rtlCol="0" anchor="ctr" wrap="square" lIns="73152" rIns="73152" bIns="36576"/>
+          <a:lstStyle/>
+          <a:p>
+            <a:pPr algn="ctr">
+              <a:defRPr sz="1150" b="1">
+                <a:solidFill>
+                  <a:srgbClr val="0B2E59"/>
+                </a:solidFill>
+                <a:latin typeface="Segoe UI"/>
+              </a:defRPr>
+            </a:pPr>
+            <a:r>
+              <a:t>Block vs annotate</a:t>
+            </a:r>
+          </a:p>
+          <a:p>
+            <a:pPr algn="ctr">
+              <a:defRPr sz="1150" b="1">
+                <a:solidFill>
+                  <a:srgbClr val="0B2E59"/>
+                </a:solidFill>
+                <a:latin typeface="Segoe UI"/>
+              </a:defRPr>
+            </a:pPr>
+            <a:r>
+              <a:t>At the threshold: blocked, HTTP 400, Failed trace.</a:t>
+            </a:r>
+          </a:p>
+          <a:p>
+            <a:pPr algn="ctr">
+              <a:defRPr sz="1150" b="1">
+                <a:solidFill>
+                  <a:srgbClr val="0B2E59"/>
+                </a:solidFill>
+                <a:latin typeface="Segoe UI"/>
+              </a:defRPr>
+            </a:pPr>
+            <a:r>
+              <a:t>Below it: answered, severity recorded.</a:t>
+            </a:r>
+          </a:p>
+        </p:txBody>
+      </p:sp>
+      <p:sp>
+        <p:nvSpPr>
+          <p:cNvPr id="9" name="Rounded Rectangle 8"/>
+          <p:cNvSpPr/>
+          <p:nvPr/>
+        </p:nvSpPr>
+        <p:spPr>
+          <a:xfrm>
+            <a:off x="4434840" y="4389120"/>
+            <a:ext cx="3749039" cy="1417320"/>
           </a:xfrm>
           <a:prstGeom prst="roundRect">
             <a:avLst/>
@@ -11390,7 +11715,7 @@
           <a:lstStyle/>
           <a:p>
             <a:pPr algn="ctr">
-              <a:defRPr sz="1270" b="1">
+              <a:defRPr sz="1150" b="1">
                 <a:solidFill>
                   <a:srgbClr val="0B2E59"/>
                 </a:solidFill>
@@ -11403,7 +11728,7 @@
           </a:p>
           <a:p>
             <a:pPr algn="ctr">
-              <a:defRPr sz="1270" b="1">
+              <a:defRPr sz="1150" b="1">
                 <a:solidFill>
                   <a:srgbClr val="0B2E59"/>
                 </a:solidFill>
@@ -11418,14 +11743,14 @@
       </p:sp>
       <p:sp>
         <p:nvSpPr>
-          <p:cNvPr id="9" name="Rounded Rectangle 8"/>
+          <p:cNvPr id="10" name="Rounded Rectangle 9"/>
           <p:cNvSpPr/>
           <p:nvPr/>
         </p:nvSpPr>
         <p:spPr>
           <a:xfrm>
-            <a:off x="6355080" y="4160520"/>
-            <a:ext cx="4937760" cy="1417320"/>
+            <a:off x="8412480" y="4389120"/>
+            <a:ext cx="3108960" cy="1417320"/>
           </a:xfrm>
           <a:prstGeom prst="roundRect">
             <a:avLst/>
@@ -11458,7 +11783,7 @@
           <a:lstStyle/>
           <a:p>
             <a:pPr algn="ctr">
-              <a:defRPr sz="1500" b="1">
+              <a:defRPr sz="1300" b="1">
                 <a:solidFill>
                   <a:srgbClr val="0B2E59"/>
                 </a:solidFill>
@@ -11471,7 +11796,7 @@
           </a:p>
           <a:p>
             <a:pPr algn="ctr">
-              <a:defRPr sz="1500" b="1">
+              <a:defRPr sz="1300" b="1">
                 <a:solidFill>
                   <a:srgbClr val="0B2E59"/>
                 </a:solidFill>
@@ -11484,7 +11809,7 @@
           </a:p>
           <a:p>
             <a:pPr algn="ctr">
-              <a:defRPr sz="1500" b="1">
+              <a:defRPr sz="1300" b="1">
                 <a:solidFill>
                   <a:srgbClr val="0B2E59"/>
                 </a:solidFill>
@@ -12762,7 +13087,7 @@
               </a:defRPr>
             </a:pPr>
             <a:r>
-              <a:t>approx. US$0.36/h; approx. US$259/month if left on</a:t>
+              <a:t>approx. US$0.36/h; approx. US$259/month if left on; F4 doubles it</a:t>
             </a:r>
           </a:p>
         </p:txBody>
@@ -13996,7 +14321,7 @@
                           </a:solidFill>
                           <a:latin typeface="Segoe UI"/>
                         </a:rPr>
-                        <a:t>Compare model-router vs gpt-4.1-mini; read router pick in trace</a:t>
+                        <a:t>Compare model-router vs gpt-4.1-mini; read the router's pick in the model-router playground</a:t>
                       </a:r>
                     </a:p>
                   </a:txBody>
@@ -18019,8 +18344,8 @@
         </p:nvSpPr>
         <p:spPr>
           <a:xfrm>
-            <a:off x="502920" y="1828800"/>
-            <a:ext cx="2057400" cy="1234440"/>
+            <a:off x="502920" y="1691640"/>
+            <a:ext cx="2057400" cy="777240"/>
           </a:xfrm>
           <a:prstGeom prst="chevron">
             <a:avLst/>
@@ -18053,7 +18378,7 @@
           <a:lstStyle/>
           <a:p>
             <a:pPr algn="ctr">
-              <a:defRPr sz="1300" b="1">
+              <a:defRPr sz="1500" b="1">
                 <a:solidFill>
                   <a:srgbClr val="0B2E59"/>
                 </a:solidFill>
@@ -18064,11 +18389,34 @@
               <a:t>Unify</a:t>
             </a:r>
           </a:p>
+        </p:txBody>
+      </p:sp>
+      <p:sp>
+        <p:nvSpPr>
+          <p:cNvPr id="8" name="TextBox 7"/>
+          <p:cNvSpPr txBox="1"/>
+          <p:nvPr/>
+        </p:nvSpPr>
+        <p:spPr>
+          <a:xfrm>
+            <a:off x="594360" y="2606040"/>
+            <a:ext cx="1874519" cy="1005840"/>
+          </a:xfrm>
+          <a:prstGeom prst="rect">
+            <a:avLst/>
+          </a:prstGeom>
+          <a:noFill/>
+        </p:spPr>
+        <p:txBody>
+          <a:bodyPr wrap="square" lIns="73152" rIns="73152" bIns="36576" anchor="t">
+            <a:spAutoFit/>
+          </a:bodyPr>
+          <a:lstStyle/>
           <a:p>
             <a:pPr algn="ctr">
-              <a:defRPr sz="1300" b="1">
-                <a:solidFill>
-                  <a:srgbClr val="0B2E59"/>
+              <a:defRPr sz="1250" b="0">
+                <a:solidFill>
+                  <a:srgbClr val="333333"/>
                 </a:solidFill>
                 <a:latin typeface="Segoe UI"/>
               </a:defRPr>
@@ -18081,14 +18429,14 @@
       </p:sp>
       <p:sp>
         <p:nvSpPr>
-          <p:cNvPr id="8" name="Chevron 7"/>
+          <p:cNvPr id="9" name="Chevron 8"/>
           <p:cNvSpPr/>
           <p:nvPr/>
         </p:nvSpPr>
         <p:spPr>
           <a:xfrm>
-            <a:off x="2743200" y="1828800"/>
-            <a:ext cx="2057400" cy="1234440"/>
+            <a:off x="2743200" y="1691640"/>
+            <a:ext cx="2057400" cy="777240"/>
           </a:xfrm>
           <a:prstGeom prst="chevron">
             <a:avLst/>
@@ -18121,7 +18469,7 @@
           <a:lstStyle/>
           <a:p>
             <a:pPr algn="ctr">
-              <a:defRPr sz="1300" b="1">
+              <a:defRPr sz="1500" b="1">
                 <a:solidFill>
                   <a:srgbClr val="0B2E59"/>
                 </a:solidFill>
@@ -18132,11 +18480,34 @@
               <a:t>Govern</a:t>
             </a:r>
           </a:p>
+        </p:txBody>
+      </p:sp>
+      <p:sp>
+        <p:nvSpPr>
+          <p:cNvPr id="10" name="TextBox 9"/>
+          <p:cNvSpPr txBox="1"/>
+          <p:nvPr/>
+        </p:nvSpPr>
+        <p:spPr>
+          <a:xfrm>
+            <a:off x="2834640" y="2606040"/>
+            <a:ext cx="1874519" cy="1005840"/>
+          </a:xfrm>
+          <a:prstGeom prst="rect">
+            <a:avLst/>
+          </a:prstGeom>
+          <a:noFill/>
+        </p:spPr>
+        <p:txBody>
+          <a:bodyPr wrap="square" lIns="73152" rIns="73152" bIns="36576" anchor="t">
+            <a:spAutoFit/>
+          </a:bodyPr>
+          <a:lstStyle/>
           <a:p>
             <a:pPr algn="ctr">
-              <a:defRPr sz="1300" b="1">
-                <a:solidFill>
-                  <a:srgbClr val="0B2E59"/>
+              <a:defRPr sz="1250" b="0">
+                <a:solidFill>
+                  <a:srgbClr val="333333"/>
                 </a:solidFill>
                 <a:latin typeface="Segoe UI"/>
               </a:defRPr>
@@ -18149,14 +18520,14 @@
       </p:sp>
       <p:sp>
         <p:nvSpPr>
-          <p:cNvPr id="9" name="Chevron 8"/>
+          <p:cNvPr id="11" name="Chevron 10"/>
           <p:cNvSpPr/>
           <p:nvPr/>
         </p:nvSpPr>
         <p:spPr>
           <a:xfrm>
-            <a:off x="4983480" y="1828800"/>
-            <a:ext cx="2057400" cy="1234440"/>
+            <a:off x="4983480" y="1691640"/>
+            <a:ext cx="2057400" cy="777240"/>
           </a:xfrm>
           <a:prstGeom prst="chevron">
             <a:avLst/>
@@ -18189,7 +18560,7 @@
           <a:lstStyle/>
           <a:p>
             <a:pPr algn="ctr">
-              <a:defRPr sz="1300" b="1">
+              <a:defRPr sz="1500" b="1">
                 <a:solidFill>
                   <a:srgbClr val="0B2E59"/>
                 </a:solidFill>
@@ -18200,11 +18571,34 @@
               <a:t>Personalise</a:t>
             </a:r>
           </a:p>
+        </p:txBody>
+      </p:sp>
+      <p:sp>
+        <p:nvSpPr>
+          <p:cNvPr id="12" name="TextBox 11"/>
+          <p:cNvSpPr txBox="1"/>
+          <p:nvPr/>
+        </p:nvSpPr>
+        <p:spPr>
+          <a:xfrm>
+            <a:off x="5074920" y="2606040"/>
+            <a:ext cx="1874519" cy="1005840"/>
+          </a:xfrm>
+          <a:prstGeom prst="rect">
+            <a:avLst/>
+          </a:prstGeom>
+          <a:noFill/>
+        </p:spPr>
+        <p:txBody>
+          <a:bodyPr wrap="square" lIns="73152" rIns="73152" bIns="36576" anchor="t">
+            <a:spAutoFit/>
+          </a:bodyPr>
+          <a:lstStyle/>
           <a:p>
             <a:pPr algn="ctr">
-              <a:defRPr sz="1300" b="1">
-                <a:solidFill>
-                  <a:srgbClr val="0B2E59"/>
+              <a:defRPr sz="1250" b="0">
+                <a:solidFill>
+                  <a:srgbClr val="333333"/>
                 </a:solidFill>
                 <a:latin typeface="Segoe UI"/>
               </a:defRPr>
@@ -18217,14 +18611,14 @@
       </p:sp>
       <p:sp>
         <p:nvSpPr>
-          <p:cNvPr id="10" name="Chevron 9"/>
+          <p:cNvPr id="13" name="Chevron 12"/>
           <p:cNvSpPr/>
           <p:nvPr/>
         </p:nvSpPr>
         <p:spPr>
           <a:xfrm>
-            <a:off x="7223760" y="1828800"/>
-            <a:ext cx="2057400" cy="1234440"/>
+            <a:off x="7223760" y="1691640"/>
+            <a:ext cx="2057400" cy="777240"/>
           </a:xfrm>
           <a:prstGeom prst="chevron">
             <a:avLst/>
@@ -18257,7 +18651,7 @@
           <a:lstStyle/>
           <a:p>
             <a:pPr algn="ctr">
-              <a:defRPr sz="1300" b="1">
+              <a:defRPr sz="1500" b="1">
                 <a:solidFill>
                   <a:srgbClr val="0B2E59"/>
                 </a:solidFill>
@@ -18268,11 +18662,34 @@
               <a:t>Converse</a:t>
             </a:r>
           </a:p>
+        </p:txBody>
+      </p:sp>
+      <p:sp>
+        <p:nvSpPr>
+          <p:cNvPr id="14" name="TextBox 13"/>
+          <p:cNvSpPr txBox="1"/>
+          <p:nvPr/>
+        </p:nvSpPr>
+        <p:spPr>
+          <a:xfrm>
+            <a:off x="7315200" y="2606040"/>
+            <a:ext cx="1874519" cy="1005840"/>
+          </a:xfrm>
+          <a:prstGeom prst="rect">
+            <a:avLst/>
+          </a:prstGeom>
+          <a:noFill/>
+        </p:spPr>
+        <p:txBody>
+          <a:bodyPr wrap="square" lIns="73152" rIns="73152" bIns="36576" anchor="t">
+            <a:spAutoFit/>
+          </a:bodyPr>
+          <a:lstStyle/>
           <a:p>
             <a:pPr algn="ctr">
-              <a:defRPr sz="1300" b="1">
-                <a:solidFill>
-                  <a:srgbClr val="0B2E59"/>
+              <a:defRPr sz="1250" b="0">
+                <a:solidFill>
+                  <a:srgbClr val="333333"/>
                 </a:solidFill>
                 <a:latin typeface="Segoe UI"/>
               </a:defRPr>
@@ -18285,14 +18702,14 @@
       </p:sp>
       <p:sp>
         <p:nvSpPr>
-          <p:cNvPr id="11" name="Chevron 10"/>
+          <p:cNvPr id="15" name="Chevron 14"/>
           <p:cNvSpPr/>
           <p:nvPr/>
         </p:nvSpPr>
         <p:spPr>
           <a:xfrm>
-            <a:off x="9464040" y="1828800"/>
-            <a:ext cx="2057400" cy="1234440"/>
+            <a:off x="9464040" y="1691640"/>
+            <a:ext cx="2057400" cy="777240"/>
           </a:xfrm>
           <a:prstGeom prst="chevron">
             <a:avLst/>
@@ -18325,7 +18742,7 @@
           <a:lstStyle/>
           <a:p>
             <a:pPr algn="ctr">
-              <a:defRPr sz="1300" b="1">
+              <a:defRPr sz="1500" b="1">
                 <a:solidFill>
                   <a:srgbClr val="FFFFFF"/>
                 </a:solidFill>
@@ -18336,31 +18753,18 @@
               <a:t>Coach &amp; Act</a:t>
             </a:r>
           </a:p>
-          <a:p>
-            <a:pPr algn="ctr">
-              <a:defRPr sz="1300" b="1">
-                <a:solidFill>
-                  <a:srgbClr val="FFFFFF"/>
-                </a:solidFill>
-                <a:latin typeface="Segoe UI"/>
-              </a:defRPr>
-            </a:pPr>
-            <a:r>
-              <a:t>Foundry agent talks to Rahim and takes approved action</a:t>
-            </a:r>
-          </a:p>
-        </p:txBody>
-      </p:sp>
-      <p:sp>
-        <p:nvSpPr>
-          <p:cNvPr id="12" name="TextBox 11"/>
+        </p:txBody>
+      </p:sp>
+      <p:sp>
+        <p:nvSpPr>
+          <p:cNvPr id="16" name="TextBox 15"/>
           <p:cNvSpPr txBox="1"/>
           <p:nvPr/>
         </p:nvSpPr>
         <p:spPr>
           <a:xfrm>
-            <a:off x="713232" y="1078992"/>
-            <a:ext cx="5577840" cy="320040"/>
+            <a:off x="9555480" y="2606040"/>
+            <a:ext cx="1874519" cy="1005840"/>
           </a:xfrm>
           <a:prstGeom prst="rect">
             <a:avLst/>
@@ -18373,30 +18777,30 @@
           </a:bodyPr>
           <a:lstStyle/>
           <a:p>
-            <a:pPr algn="l">
-              <a:defRPr sz="1600" b="1">
-                <a:solidFill>
-                  <a:srgbClr val="333333"/>
-                </a:solidFill>
-                <a:latin typeface="Segoe UI"/>
-              </a:defRPr>
-            </a:pPr>
-            <a:r>
-              <a:t>Fabric workshop: Resident 360 sees Rahim</a:t>
-            </a:r>
-          </a:p>
-        </p:txBody>
-      </p:sp>
-      <p:sp>
-        <p:nvSpPr>
-          <p:cNvPr id="13" name="TextBox 12"/>
+            <a:pPr algn="ctr">
+              <a:defRPr sz="1250" b="1">
+                <a:solidFill>
+                  <a:srgbClr val="0F7C8C"/>
+                </a:solidFill>
+                <a:latin typeface="Segoe UI"/>
+              </a:defRPr>
+            </a:pPr>
+            <a:r>
+              <a:t>Foundry agent talks to Rahim and takes approved action</a:t>
+            </a:r>
+          </a:p>
+        </p:txBody>
+      </p:sp>
+      <p:sp>
+        <p:nvSpPr>
+          <p:cNvPr id="17" name="TextBox 16"/>
           <p:cNvSpPr txBox="1"/>
           <p:nvPr/>
         </p:nvSpPr>
         <p:spPr>
           <a:xfrm>
-            <a:off x="7315200" y="1078992"/>
-            <a:ext cx="4114800" cy="320040"/>
+            <a:off x="713232" y="1078992"/>
+            <a:ext cx="5577840" cy="320040"/>
           </a:xfrm>
           <a:prstGeom prst="rect">
             <a:avLst/>
@@ -18412,6 +18816,42 @@
             <a:pPr algn="l">
               <a:defRPr sz="1600" b="1">
                 <a:solidFill>
+                  <a:srgbClr val="333333"/>
+                </a:solidFill>
+                <a:latin typeface="Segoe UI"/>
+              </a:defRPr>
+            </a:pPr>
+            <a:r>
+              <a:t>Fabric workshop: Resident 360 sees Rahim</a:t>
+            </a:r>
+          </a:p>
+        </p:txBody>
+      </p:sp>
+      <p:sp>
+        <p:nvSpPr>
+          <p:cNvPr id="18" name="TextBox 17"/>
+          <p:cNvSpPr txBox="1"/>
+          <p:nvPr/>
+        </p:nvSpPr>
+        <p:spPr>
+          <a:xfrm>
+            <a:off x="7315200" y="1078992"/>
+            <a:ext cx="4114800" cy="320040"/>
+          </a:xfrm>
+          <a:prstGeom prst="rect">
+            <a:avLst/>
+          </a:prstGeom>
+          <a:noFill/>
+        </p:spPr>
+        <p:txBody>
+          <a:bodyPr wrap="square" lIns="73152" rIns="73152" bIns="36576" anchor="t">
+            <a:spAutoFit/>
+          </a:bodyPr>
+          <a:lstStyle/>
+          <a:p>
+            <a:pPr algn="l">
+              <a:defRPr sz="1600" b="1">
+                <a:solidFill>
                   <a:srgbClr val="0F7C8C"/>
                 </a:solidFill>
                 <a:latin typeface="Segoe UI"/>
@@ -18425,7 +18865,7 @@
       </p:sp>
       <p:sp>
         <p:nvSpPr>
-          <p:cNvPr id="14" name="Rounded Rectangle 13"/>
+          <p:cNvPr id="19" name="Rounded Rectangle 18"/>
           <p:cNvSpPr/>
           <p:nvPr/>
         </p:nvSpPr>
@@ -18745,7 +19185,7 @@
               </a:defRPr>
             </a:pPr>
             <a:r>
-              <a:t>Foundry IQ + profile + memory; never Fabric</a:t>
+              <a:t>Foundry IQ + profile + memory; Fabric once, age band only</a:t>
             </a:r>
           </a:p>
         </p:txBody>
@@ -19290,7 +19730,7 @@
                           </a:solidFill>
                           <a:latin typeface="Segoe UI"/>
                         </a:rPr>
-                        <a:t>Rahim asks for hazy-day indoor activities; Mei asks the aggregate region question via Fabric.</a:t>
+                        <a:t>Rahim gets hazy-day activities with approval, then asks which programme people his age stick with (one age-band Fabric question); Mei asks the region question.</a:t>
                       </a:r>
                     </a:p>
                   </a:txBody>
@@ -19474,7 +19914,7 @@
                           </a:solidFill>
                           <a:latin typeface="Segoe UI"/>
                         </a:rPr>
-                        <a:t>The bridge closes on multi-hop aggregate reasoning and why Fabric IQ is for officer questions.</a:t>
+                        <a:t>The bridge closes on multi-hop aggregate reasoning and why Fabric IQ only ever receives aggregate questions.</a:t>
                       </a:r>
                     </a:p>
                   </a:txBody>
@@ -19539,7 +19979,7 @@
               </a:defRPr>
             </a:pPr>
             <a:r>
-              <a:t>Routing rule: citizen questions stay with Foundry IQ, profile tools and memory; officer aggregate questions may call Fabric.</a:t>
+              <a:t>Routing rule: guidance stays with Foundry IQ, profile and memory; only aggregate questions (cohort, region, programme) go to Fabric.</a:t>
             </a:r>
           </a:p>
         </p:txBody>
@@ -20131,7 +20571,7 @@
               </a:defRPr>
             </a:pPr>
             <a:r>
-              <a:t>get_citizen_profile</a:t>
+              <a:t>livewell_profile</a:t>
             </a:r>
           </a:p>
           <a:p>
@@ -20144,7 +20584,7 @@
               </a:defRPr>
             </a:pPr>
             <a:r>
-              <a:t>resident_360 extract</a:t>
+              <a:t>resident profile extract</a:t>
             </a:r>
           </a:p>
         </p:txBody>
@@ -20510,7 +20950,7 @@
               </a:defRPr>
             </a:pPr>
             <a:r>
-              <a:t>Fabric F2</a:t>
+              <a:t>Fabric F2 / F4</a:t>
             </a:r>
           </a:p>
           <a:p>
@@ -22172,7 +22612,7 @@
               </a:defRPr>
             </a:pPr>
             <a:r>
-              <a:t>Agent introduces itself, states it is not a doctor, and refuses to diagnose.</a:t>
+              <a:t>Agent introduces itself, says it is not a doctor and refuses to diagnose; the model-router playground shows which model it picked.</a:t>
             </a:r>
           </a:p>
         </p:txBody>
@@ -22956,7 +23396,7 @@
               </a:defRPr>
             </a:pPr>
             <a:r>
-              <a:t>Pre-diabetes food question cites at least one KB document and invents no source.</a:t>
+              <a:t>Pre-diabetes food question cites at least one KB document; the supplement question routes to a clinician with no invented source.</a:t>
             </a:r>
           </a:p>
         </p:txBody>

</xml_diff>

<commit_message>
Participants use their own workshop accounts; printable sign-in cards
- Lab 0 (both rails), the Fabric step, the README, the values sheet and both
  decks say "your own workshop account" instead of hpb.labNN; decks rebuilt.
- check_setup.py warns when the account is not in a workshop tenant (for
  example a work account) instead of on every non-hpb.lab account.
- workshop.yaml lab_accounts.naming: named -> the values sheet shows
  firstname.lastname@<tenant>.
- scripts/tenant/sign-in-cards.py: one A4 card per participant (username,
  temporary password, first sign-in steps) from attendees.txt or the
  lab-accounts CSV, written to the gitignored .azure/<env>/.

Co-authored-by: Copilot App <223556219+Copilot@users.noreply.github.com>
</commit_message>
<xml_diff>
--- a/deck/LiveWell-Foundry-Workshop-Day1.pptx
+++ b/deck/LiveWell-Foundry-Workshop-Day1.pptx
@@ -1431,7 +1431,7 @@
           <a:lstStyle/>
           <a:p>
             <a:r>
-              <a:t>Cover this before anyone opens the portal because sign-in is the first likely delay. Use the TODO labels visibly if the final Wi-Fi values have not been confirmed. Ask participants to use their hpb.labNN account for all Foundry and Fabric steps. Gate: move on when everyone has Wi-Fi, Authenticator registration started and the correct account ready.</a:t>
+              <a:t>Cover this before anyone opens the portal because sign-in is the first likely delay. Use the TODO labels visibly if the final Wi-Fi values have not been confirmed. Ask participants to use their own workshop account (the username on their sign-in card) for all Foundry and Fabric steps. Gate: move on when everyone has Wi-Fi, Authenticator registration started and the correct account ready.</a:t>
             </a:r>
           </a:p>
         </p:txBody>
@@ -18046,7 +18046,7 @@
               </a:defRPr>
             </a:pPr>
             <a:r>
-              <a:t>• Use your hpb.labNN account for Foundry portal, Fabric and workshop scripts.</a:t>
+              <a:t>• Use your own workshop account (on your sign-in card) for Foundry portal, Fabric and workshop scripts.</a:t>
             </a:r>
           </a:p>
           <a:p>

</xml_diff>